<commit_message>
Deck v4: no slide without a picture — six text slides made visual
Per the Prof G visualize rule, the six text-only survivors each got a
real visual: the business is now a flywheel plus a licence-tier
staircase; the ask is a 90-day timeline with the commercial gate drawn
as a literal gate; the demo closer carries a live screenshot of the
ledger's own countdown ("1 day — until 20 August, when XPTUSD 1 month is
checked"); governance is the five-node review gauntlet with the named
human reviewer in gold; method is the two pipelines (prices, filings)
converging on the site with the rejected-technique discard bin drawn in;
and the alternatives page is a verdict matrix whose status-quo cell
reads TELEGRAM. Displaced body copy moved into each slide's speaker
notes as the spoken track. Numbers unchanged, verified against main
HEAD 685ecd3 earlier today.

Co-Authored-By: Claude Fable 5 <noreply@anthropic.com>
Claude-Session: https://claude.ai/code/session_019HtsB7KapvkSNaceBBiqHq
</commit_message>
<xml_diff>
--- a/docs/partnership/Testahil_partnership_18_August_2026.pptx
+++ b/docs/partnership/Testahil_partnership_18_August_2026.pptx
@@ -1384,8 +1384,8 @@
           <a:p>
             <a:r>
               <a:rPr lang="en-US" dirty="0"/>
-              <a:t>PURPOSE: get out of the slides and into the product while the room is still leaning forward — with the countdown line as the hook that makes them open the site tonight.
-The countdown is real: the ledger page shows "next forecast resolves in N days" against a named instrument and date (at deck time: XPTUSD's 1-month, 20-Aug-2026) — check it live before the meeting and say the actual name and date aloud.
+              <a:t>PURPOSE: get out of the slides and into the product while the room is leaning forward — with the site's own countdown clock, screenshotted live, as the hook that makes them open the ledger tonight.
+The countdown is real and self-updating on the site: at capture (18-Aug) it read "1 day — until 20 August 2026, when XPTUSD 1 month is checked against the real price". Check it live before the meeting and say the actual instrument and date aloud; if the screenshot has aged, retake it (the deck source rebuilds it in one command).
 Demo route that lands hardest, in order: (1) the Ticker Picker — sort by reachability, flip the horizon, show the red read-this-first box: honesty as a feature; (2) one ticker page (Fertiglobe or ADNOC L&amp;S) — the odds card, the cone, "Open the study / model / source register"; (3) the Ledger — "Were we right?", 12/13, the countdown, Samsung kept red on the record.
 ——— JARGON ON THIS SLIDE ———
 Validation study / leave-behind — a full worked example on one company (Tata Motors) with every assumption and source on the record, handed over for their specialists to attack afterwards.
@@ -1477,8 +1477,7 @@
           <a:p>
             <a:r>
               <a:rPr lang="en-US" dirty="0"/>
-              <a:t>PURPOSE: the slide built to be forwarded — compliance, model-risk and vendor-risk decide this deal before any regulator is consulted, and they will read this page without Sherif in the room.
-Three answers: what publishes (ranges, never recommendations), who is accountable (a named human reviewer — under integration, the partner's own analyst), what can be inspected (fixed seed, documentation, the rejected-technique list, an append-only ledger). The regulator line moved here from the miss slide — this is the reader it was written for.
+              <a:t>PURPOSE: the forwarded slide — compliance, model-risk and vendor-risk decide this deal before any regulator is consulted. The gauntlet drawing answers their three questions in one line of sight: what publishes (ranges only — never a rating, target or recommendation; the public site is education only, advice happens inside the partner's perimeter, given by their licensed people), who is accountable (a NAMED human reviewer before every release — under integration, the partner's own analyst; the gold node is the point), and what can be inspected (fixed-seed reproducible runs, full documentation, every rejected technique named, an append-only ledger).
 ——— LIKELY QUESTIONS ———
 "What if you are hit by a bus?" — the pipeline is documented to the standard where an independent quant can reproduce it. Offer the reproduction test as evidence.
 "Is this AI making recommendations?" — no. It publishes distributions. The recommendation, if any, is made by the partner's licensed staff.
@@ -1576,16 +1575,15 @@
           <a:p>
             <a:r>
               <a:rPr lang="en-US" dirty="0"/>
-              <a:t>PURPOSE: one page for the quant who will try to break it — engine, gate, and filings-only fundamentals, including what was tested and thrown away (the rejected list says as much as the kept one).
+              <a:t>PURPOSE: one drawing for the quant who will try to break it — both pipelines end to end, and the discard bin in plain sight. What a research shop threw away says as much as what it kept; showing the bin IS the credibility move.
 ——— JARGON ON THIS SLIDE ———
-Carry / carry-anchored — the return for simply holding the asset (local risk-free minus yield); the simulation is centred on it, not on a predicted direction.
-YZ / HAR / t — volatility measured from open-high-low-close (captures overnight gaps); blended across daily/weekly/monthly speeds (volatility clusters); fat-tailed bell curve (extreme moves rare but real). Tail and width fitted PER MARKET — Cairo and New York do not crash the same way.
-Data-quality gate — every price file passes an automated check first: each exchange's own daily price limit defines what one session can physically do (Egypt ±20%, Korea ±30%), so impossible moves are caught without a guessed global threshold.
-PASS / PARITY / FAIL — beats a carry-anchored random-walk benchmark with confidence / honestly calibrated but no proven edge yet / benchmark won. All published.
-CRPS-tuning — looked better in-sample and LOST out of sample; the standing promotion rule (nothing ships without surviving the same out-of-sample test the forecasts face) exists because of it.
-The beta rule — adopted 10-Aug-2026: every beta regresses on the exchange's published index (EGX30, FADGI, TASI, …), never a composite of covered names; every legacy beta was re-derived. On the first name run both ways the composite understated beta ~40% and overstated fair value 21.6%.
-——— NUMBER PROVENANCE ———
-"One robust name-level FAIL" — EXTRA (United Electronics, Tadawul), read live from the fit registry 18-Aug-2026; kept on the record, unedited. v1 said "three" from an older registry state — the count is volatile; always re-read before presenting.</a:t>
+Carry-anchored — the simulation is centred on carry (local risk-free minus yield), not on a predicted direction — so claimed skill can never secretly be the time value of money.
+YZ-HAR-t — volatility measured from open-high-low-close (captures overnight gaps); blended across daily/weekly/monthly speeds (volatility clusters); fat-tailed bell curve (extreme moves rare but real). Tail and width fitted PER MARKET — Cairo and New York do not crash the same way; Egypt adds a history-gated per-name width overlay.
+Step-0 gate — every price file passes an automated check first: each exchange's own daily price limit defines what one session can physically do (Egypt ±20%, Korea ±30%), so impossible moves are caught without a guessed global threshold.
+The exam / verdicts — walk-forward, non-overlapping windows scored against a carry-anchored random-walk benchmark; PASS (beats it with confidence) / PARITY (honestly calibrated, no proven edge) / FAIL (benchmark won), published per name and per market. One statistically robust name-level FAIL is on the record today — EXTRA (Tadawul), read live from the fit registry 18-Aug-2026 (v1 said "three" from an older registry state; the count is volatile, re-read before presenting).
+The bin — CRPS-tuned selection looked better in-sample and LOST out of sample; the standing promotion rule (nothing ships unless it survives the same out-of-sample exam the forecasts face) exists because of it.
+The beta rule — adopted 10-Aug-2026: every beta regresses on the published index of the stock's own exchange (EGX30, FADGI, TASI, …), never a composite of covered names; every legacy beta was re-derived. On the first name run both ways the composite understated beta ~40% and overstated fair value 21.6%.
+Filings lane — official audited accounts only, never vendor feeds; ground-up volume × price and cost per unit; a live formula chain drivers → IS → BS → CF → DCF; debt split local vs foreign currency; working capital projected, not plugged; output is a range, never a point.</a:t>
             </a:r>
             <a:endParaRPr lang="en-US" dirty="0"/>
           </a:p>
@@ -1767,13 +1765,13 @@
           <a:p>
             <a:r>
               <a:rPr lang="en-US" dirty="0"/>
-              <a:t>PURPOSE: kill the three escape routes — "our vendor can add this", "we'll build it", "we'll wait" — before procurement raises them. Order matters: concede the category first (vendors are paid B2B businesses, brokers already budget for exactly this), then narrow to the part they do not reach. Never argue you are better at what they already do well.
+              <a:t>PURPOSE: kill the three escape routes — "our vendor can add this", "we'll build it", "we'll wait" — in one scannable verdict matrix, with the Testahil row reading green across. The TELEGRAM pill is the sting: for the long tail, doing nothing has a research provider, and it is Telegram.
+SPOKEN TRACK per row — Vendors: Trading Central, Morningstar and peers already sell analytics into brokers, which proves the category rather than closing it; their emphasis is developed-market equities, FX, indices and commodities from vendor feeds — EGX/ADX/Tadawul small and mid caps rebuilt from the companies' own filings is the part they do not reach ("NOT HERE": their products are live, just not for these names). Build: a capable quant desk can rebuild a cone engine in months, but a time-stamped public record with the misses kept cannot be rebuilt — only started, and ours started June 2026; building also moves the model risk onto the bank's own balance sheet. Do nothing: the long tail's current research provider is Telegram tips and social media — the churn machine. Order matters when speaking: concede the category first; never argue you are better at what vendors already do well.
 ——— IF PRESSED ———
 "They could add local coverage." They could. It would take the same fifteen years of restated local price history and the same filings work, and their public record would still start at zero.
 "Their brand is stronger." Yes. That is why this is offered under YOUR brand, not ours.
-——— JARGON ———
-Vendor feed — pre-packaged price and fundamentals data, a step removed from the filed accounts.
-Model risk on your balance sheet — build it yourself and you own its failures; buy it and part of that sits with the supplier.</a:t>
+——— HOW THESE CELLS ARE FILLED ———
+91 NAMES / SINCE JUN-26 — the live coverage count and the earliest ledger anchor (11-Jun-2026), cover-note method. The other cells are characterisations argued in the spoken track, not measurements — keep them defensible: "NOT HERE" (coverage focus), "STARTS AT 0" (any new public record), "TELEGRAM" (the status-quo provider for uncovered names).</a:t>
             </a:r>
             <a:endParaRPr lang="en-US" dirty="0"/>
           </a:p>
@@ -2541,11 +2539,12 @@
           <a:p>
             <a:r>
               <a:rPr lang="en-US" dirty="0"/>
-              <a:t>PURPOSE: give the budget holder the two revenue mechanics in one look — the engine grows the market itself, and it is licensed once, deeply, per partner. No invented pricing; the model shape, not fabricated numbers.
+              <a:t>PURPOSE: give the budget holder the two revenue mechanics in one picture — the engine grows the market itself (flywheel), and it is licensed once, deeply, per partner (the tier staircase). No invented pricing; the model shape, not fabricated numbers.
+SPOKEN TRACK (the old body copy, now said aloud over the drawing): Capture the new-investor wave — and create it: people who never invested because they couldn't read the research finally get information they can act on, and informed odds bring first-timers into ME/EM exchanges and keep them. One deep integration, delivered white-label or by API under the partner's umbrella; premium modules — Ticker Picker, Compare, Trade, Portfolio — roll out as licensed tiers, not giveaways. The partner's return: engagement, retention, volume, and first-mover ownership of publicly-graded AI research in their markets.
 ——— JARGON ON THIS SLIDE ———
 Licence — a recurring fee for the right to run the engine, not research reports bought one at a time.
 White-label / API — under the bank's own brand with the Testahil name invisible / a data pipe the bank's own app renders inside its own interface.
-Feature tier — pricing steps: base cones at one level; Ticker Picker, Compare, Trade, Portfolio in higher tiers.
+Feature tier — the staircase: base cones at one level; Ticker Picker, Compare, Trade, Portfolio above it.
 Marginal cost — what one more market, language or stock costs. Near zero once the engine exists — the whole economics of the model.
 First-mover — the first bank in the region to OWN publicly graded AI research, before a competitor does.</a:t>
             </a:r>
@@ -2635,16 +2634,12 @@
           <a:p>
             <a:r>
               <a:rPr lang="en-US" dirty="0"/>
-              <a:t>PURPOSE: one slide the sponsor can screenshot into an internal email — the three phases, the conversion gate, and the deadline, nothing else. (v2's separate commercial-frame slide is folded into the gold gate bar; its full logic lives in these notes.)
+              <a:t>PURPOSE: one screenshot-able picture the sponsor can forward internally — gate, pilot, answer, integrate, expand, with the dates and numbers on it. The gate is drawn as a literal gate: nothing starts until price, budget holder and timeline exist.
 Why the gate exists: a free pilot with no pre-agreed price, no named budget holder and no procurement timeline is unpaid consulting. Banks convert pilots when someone with budget authority commits in advance; they stall when the budget conversation is deferred to the end. A pilot should end in an answer, not a delay.
-The licence, when asked: scoped by market, language, feature tier — and channel. Exclusivity where it matters, never universal: testahil.com keeps publishing publicly, because the graded record is what makes the engine credible to their compliance team. Each new market priced on its own data and residency cost. Where no licence line exists, the same value can be structured as equity, revenue share, or build-operate-transfer with a pre-agreed buyout — open on structure, not on whether there is one.
+SPOKEN TRACK per phase — Pilot: 90 days, audited, on the 25 names their clients hold most; opens with the data room (full 15-year calibration archive, every window, every cone, every miss) plus a verification script their quants run to reproduce the 90.6% before any client sees a number (v1 offered 89.6% on 3,373 windows; the archive now reproduces 90.6% on 3,944 — the number updates with the record). Integrate: under their umbrella, white-label pages or API; their analysts become the review layer, so the output is their firm's process, not a third party's black box. Expand: a joint model &amp; research board — their senior analysts and quants with Testahil — approving upgrades, auditing calibration, resourcing full MENA coverage.
+The licence, when asked: scoped by market, language, feature tier — and channel. Exclusivity where it matters, never universal: testahil.com keeps publishing publicly, because the graded record is what makes the engine credible to their compliance team. Each new market priced on its own data and residency cost. Where no licence line exists: equity, revenue share, or build-operate-transfer with a pre-agreed buyout — open on structure, not on whether there is one.
 ——— ON PRICE (notes only, deliberate) ———
-No figure appears on the slide. Arrive with a range settled in your own mind — the gate commits to an agreed price before day one and the question WILL be asked. If they ask for a number first, ask for scope first (markets, languages, tiers, seats); price follows scope. If they name a number first, do not accept or reject in the room — take it away, price the scope, come back. A single buyer with no competing bid sets the price only if you let them.
-——— JARGON ———
-Data room / verification script — the full calibration archive plus code their quants run to reproduce the headline 90.6% themselves before trusting it (v1 offered 89.6% on 3,373 windows; the archive now reproduces 90.6% on 3,944 — the number updates with the record).
-"The 25 names your clients hold most" — the pilot runs on their actual book, so the test is relevant to them rather than flattering to us.
-Model board — a standing joint committee approving engine changes: oversight, not a vendor relationship.
-Build-operate-transfer / revenue share — we build and run it, they take ownership later at a price agreed today / the fee is a percentage of the revenue the engine helps generate.</a:t>
+No figure appears on the slide. Arrive with a range settled in your own mind — the gate commits to an agreed price before day one and the question WILL be asked. If they ask for a number first, ask for scope first (markets, languages, tiers, seats); price follows scope. If they name a number first, do not accept or reject in the room — take it away, price the scope, come back. A single buyer with no competing bid sets the price only if you let them.</a:t>
             </a:r>
             <a:endParaRPr lang="en-US" dirty="0"/>
           </a:p>
@@ -3800,8 +3795,8 @@
         </p:nvSpPr>
         <p:spPr>
           <a:xfrm>
-            <a:off x="594360" y="1188720"/>
-            <a:ext cx="10972800" cy="914400"/>
+            <a:off x="594360" y="1051560"/>
+            <a:ext cx="10972800" cy="822960"/>
           </a:xfrm>
           <a:prstGeom prst="rect">
             <a:avLst/>
@@ -3839,7 +3834,7 @@
         </p:nvSpPr>
         <p:spPr>
           <a:xfrm>
-            <a:off x="594360" y="2331720"/>
+            <a:off x="594360" y="2103120"/>
             <a:ext cx="10972800" cy="457200"/>
           </a:xfrm>
           <a:prstGeom prst="rect">
@@ -3892,8 +3887,8 @@
         </p:nvSpPr>
         <p:spPr>
           <a:xfrm>
-            <a:off x="594360" y="2999232"/>
-            <a:ext cx="8778240" cy="548640"/>
+            <a:off x="594360" y="2724912"/>
+            <a:ext cx="8778240" cy="502920"/>
           </a:xfrm>
           <a:prstGeom prst="rect">
             <a:avLst/>
@@ -3909,17 +3904,17 @@
               <a:buNone/>
             </a:pPr>
             <a:r>
-              <a:rPr lang="en-US" sz="1500" dirty="0">
-                <a:solidFill>
-                  <a:srgbClr val="C9D6D2"/>
-                </a:solidFill>
-                <a:latin typeface="Arial" pitchFamily="34" charset="0"/>
-                <a:ea typeface="Arial" pitchFamily="34" charset="-122"/>
-                <a:cs typeface="Arial" pitchFamily="34" charset="-120"/>
-              </a:rPr>
-              <a:t>The ledger runs a public countdown to its next grading — watch us be right or wrong in real time.</a:t>
-            </a:r>
-            <a:endParaRPr lang="en-US" sz="1500" dirty="0"/>
+              <a:rPr lang="en-US" sz="1550" i="1" dirty="0">
+                <a:solidFill>
+                  <a:srgbClr val="FFFFFF"/>
+                </a:solidFill>
+                <a:latin typeface="Arial" pitchFamily="34" charset="0"/>
+                <a:ea typeface="Arial" pitchFamily="34" charset="-122"/>
+                <a:cs typeface="Arial" pitchFamily="34" charset="-120"/>
+              </a:rPr>
+              <a:t>Every number in the demo is the same number the public sees — graded, dated, and accountable.</a:t>
+            </a:r>
+            <a:endParaRPr lang="en-US" sz="1550" dirty="0"/>
           </a:p>
         </p:txBody>
       </p:sp>
@@ -3931,8 +3926,8 @@
         </p:nvSpPr>
         <p:spPr>
           <a:xfrm>
-            <a:off x="594360" y="3675888"/>
-            <a:ext cx="8778240" cy="548640"/>
+            <a:off x="594360" y="3310128"/>
+            <a:ext cx="8778240" cy="502920"/>
           </a:xfrm>
           <a:prstGeom prst="rect">
             <a:avLst/>
@@ -3948,7 +3943,7 @@
               <a:buNone/>
             </a:pPr>
             <a:r>
-              <a:rPr lang="en-US" sz="1300" dirty="0">
+              <a:rPr lang="en-US" sz="1250" dirty="0">
                 <a:solidFill>
                   <a:srgbClr val="9FB4AF"/>
                 </a:solidFill>
@@ -3958,20 +3953,71 @@
               </a:rPr>
               <a:t>Leave-behind for your technical team: the full Tata Motors validation study — every assumption on the record.</a:t>
             </a:r>
-            <a:endParaRPr lang="en-US" sz="1300" dirty="0"/>
-          </a:p>
-        </p:txBody>
-      </p:sp>
-      <p:sp>
-        <p:nvSpPr>
-          <p:cNvPr id="8" name="Text 5"/>
-          <p:cNvSpPr/>
-          <p:nvPr/>
-        </p:nvSpPr>
-        <p:spPr>
-          <a:xfrm>
-            <a:off x="594360" y="4434840"/>
-            <a:ext cx="8778240" cy="640080"/>
+            <a:endParaRPr lang="en-US" sz="1250" dirty="0"/>
+          </a:p>
+        </p:txBody>
+      </p:sp>
+      <p:sp>
+        <p:nvSpPr>
+          <p:cNvPr id="8" name="Shape 5"/>
+          <p:cNvSpPr/>
+          <p:nvPr/>
+        </p:nvSpPr>
+        <p:spPr>
+          <a:xfrm>
+            <a:off x="594360" y="4041648"/>
+            <a:ext cx="11000232" cy="1691640"/>
+          </a:xfrm>
+          <a:prstGeom prst="roundRect">
+            <a:avLst>
+              <a:gd name="adj" fmla="val 4324"/>
+            </a:avLst>
+          </a:prstGeom>
+          <a:solidFill>
+            <a:srgbClr val="FFFFFF"/>
+          </a:solidFill>
+          <a:ln w="12700">
+            <a:solidFill>
+              <a:srgbClr val="D9E4E1"/>
+            </a:solidFill>
+            <a:prstDash val="solid"/>
+          </a:ln>
+        </p:spPr>
+      </p:sp>
+      <p:pic>
+        <p:nvPicPr>
+          <p:cNvPr id="9" name="Image 1" descr="asset_countdown.png">    </p:cNvPr>
+          <p:cNvPicPr>
+            <a:picLocks noChangeAspect="1"/>
+          </p:cNvPicPr>
+          <p:nvPr/>
+        </p:nvPicPr>
+        <p:blipFill>
+          <a:blip r:embed="rId2"/>
+          <a:stretch>
+            <a:fillRect/>
+          </a:stretch>
+        </p:blipFill>
+        <p:spPr>
+          <a:xfrm>
+            <a:off x="850392" y="4261104"/>
+            <a:ext cx="5120640" cy="1261872"/>
+          </a:xfrm>
+          <a:prstGeom prst="rect">
+            <a:avLst/>
+          </a:prstGeom>
+        </p:spPr>
+      </p:pic>
+      <p:sp>
+        <p:nvSpPr>
+          <p:cNvPr id="10" name="Text 6"/>
+          <p:cNvSpPr/>
+          <p:nvPr/>
+        </p:nvSpPr>
+        <p:spPr>
+          <a:xfrm>
+            <a:off x="6053328" y="4297680"/>
+            <a:ext cx="4709160" cy="1005840"/>
           </a:xfrm>
           <a:prstGeom prst="rect">
             <a:avLst/>
@@ -3984,32 +4030,91 @@
           <a:lstStyle/>
           <a:p>
             <a:pPr indent="0" marL="0">
-              <a:buNone/>
-            </a:pPr>
-            <a:r>
-              <a:rPr lang="en-US" sz="1600" i="1" dirty="0">
-                <a:solidFill>
-                  <a:srgbClr val="FFFFFF"/>
-                </a:solidFill>
-                <a:latin typeface="Arial" pitchFamily="34" charset="0"/>
-                <a:ea typeface="Arial" pitchFamily="34" charset="-122"/>
-                <a:cs typeface="Arial" pitchFamily="34" charset="-120"/>
-              </a:rPr>
-              <a:t>Every number you’re about to see is the same number the public sees — graded, dated, and accountable.</a:t>
-            </a:r>
-            <a:endParaRPr lang="en-US" sz="1600" dirty="0"/>
-          </a:p>
-        </p:txBody>
-      </p:sp>
-      <p:sp>
-        <p:nvSpPr>
-          <p:cNvPr id="9" name="Text 6"/>
-          <p:cNvSpPr/>
-          <p:nvPr/>
-        </p:nvSpPr>
-        <p:spPr>
-          <a:xfrm>
-            <a:off x="594360" y="5806440"/>
+              <a:lnSpc>
+                <a:spcPct val="112000"/>
+              </a:lnSpc>
+              <a:buNone/>
+            </a:pPr>
+            <a:r>
+              <a:rPr lang="en-US" sz="1250" b="1" dirty="0">
+                <a:solidFill>
+                  <a:srgbClr val="0F5147"/>
+                </a:solidFill>
+                <a:latin typeface="Arial" pitchFamily="34" charset="0"/>
+                <a:ea typeface="Arial" pitchFamily="34" charset="-122"/>
+                <a:cs typeface="Arial" pitchFamily="34" charset="-120"/>
+              </a:rPr>
+              <a:t>Live on the ledger right now: </a:t>
+            </a:r>
+            <a:pPr indent="0" marL="0">
+              <a:lnSpc>
+                <a:spcPct val="112000"/>
+              </a:lnSpc>
+              <a:buNone/>
+            </a:pPr>
+            <a:r>
+              <a:rPr lang="en-US" sz="1250" dirty="0">
+                <a:solidFill>
+                  <a:srgbClr val="0E2726"/>
+                </a:solidFill>
+                <a:latin typeface="Arial" pitchFamily="34" charset="0"/>
+                <a:ea typeface="Arial" pitchFamily="34" charset="-122"/>
+                <a:cs typeface="Arial" pitchFamily="34" charset="-120"/>
+              </a:rPr>
+              <a:t>the record so far, and a countdown to the next grading — platinum’s 1-month resolves 20 August. Watch us be right, or wrong, in real time.</a:t>
+            </a:r>
+            <a:endParaRPr lang="en-US" sz="1250" dirty="0"/>
+          </a:p>
+        </p:txBody>
+      </p:sp>
+      <p:sp>
+        <p:nvSpPr>
+          <p:cNvPr id="11" name="Text 7"/>
+          <p:cNvSpPr/>
+          <p:nvPr/>
+        </p:nvSpPr>
+        <p:spPr>
+          <a:xfrm>
+            <a:off x="6053328" y="5358384"/>
+            <a:ext cx="4663440" cy="274320"/>
+          </a:xfrm>
+          <a:prstGeom prst="rect">
+            <a:avLst/>
+          </a:prstGeom>
+          <a:noFill/>
+          <a:ln/>
+        </p:spPr>
+        <p:txBody>
+          <a:bodyPr wrap="square" lIns="0" tIns="0" rIns="0" bIns="0" rtlCol="0" anchor="ctr"/>
+          <a:lstStyle/>
+          <a:p>
+            <a:pPr indent="0" marL="0">
+              <a:buNone/>
+            </a:pPr>
+            <a:r>
+              <a:rPr lang="en-US" sz="850" i="1" dirty="0">
+                <a:solidFill>
+                  <a:srgbClr val="7A8A86"/>
+                </a:solidFill>
+                <a:latin typeface="Arial" pitchFamily="34" charset="0"/>
+                <a:ea typeface="Arial" pitchFamily="34" charset="-122"/>
+                <a:cs typeface="Arial" pitchFamily="34" charset="-120"/>
+              </a:rPr>
+              <a:t>as rendered 18 Aug 2026 · testahil.com/ledger</a:t>
+            </a:r>
+            <a:endParaRPr lang="en-US" sz="850" dirty="0"/>
+          </a:p>
+        </p:txBody>
+      </p:sp>
+      <p:sp>
+        <p:nvSpPr>
+          <p:cNvPr id="12" name="Text 8"/>
+          <p:cNvSpPr/>
+          <p:nvPr/>
+        </p:nvSpPr>
+        <p:spPr>
+          <a:xfrm>
+            <a:off x="594360" y="6080760"/>
             <a:ext cx="9144000" cy="457200"/>
           </a:xfrm>
           <a:prstGeom prst="rect">
@@ -4042,7 +4147,7 @@
       </p:sp>
       <p:sp>
         <p:nvSpPr>
-          <p:cNvPr id="10" name="Text 7"/>
+          <p:cNvPr id="13" name="Text 9"/>
           <p:cNvSpPr/>
           <p:nvPr/>
         </p:nvSpPr>
@@ -4183,7 +4288,7 @@
                 <a:ea typeface="Arial" pitchFamily="34" charset="-122"/>
                 <a:cs typeface="Arial" pitchFamily="34" charset="-120"/>
               </a:rPr>
-              <a:t>Built to survive your compliance review.</a:t>
+              <a:t>Every number runs this gauntlet.</a:t>
             </a:r>
             <a:endParaRPr lang="en-US" sz="3400" dirty="0"/>
           </a:p>
@@ -4197,8 +4302,71 @@
         </p:nvSpPr>
         <p:spPr>
           <a:xfrm>
-            <a:off x="594360" y="1783080"/>
-            <a:ext cx="3474720" cy="292608"/>
+            <a:off x="594360" y="1389888"/>
+            <a:ext cx="10789920" cy="365760"/>
+          </a:xfrm>
+          <a:prstGeom prst="rect">
+            <a:avLst/>
+          </a:prstGeom>
+          <a:noFill/>
+          <a:ln/>
+        </p:spPr>
+        <p:txBody>
+          <a:bodyPr wrap="square" lIns="0" tIns="0" rIns="0" bIns="0" rtlCol="0" anchor="t"/>
+          <a:lstStyle/>
+          <a:p>
+            <a:pPr indent="0" marL="0">
+              <a:buNone/>
+            </a:pPr>
+            <a:r>
+              <a:rPr lang="en-US" sz="1350" dirty="0">
+                <a:solidFill>
+                  <a:srgbClr val="5C6B70"/>
+                </a:solidFill>
+                <a:latin typeface="Arial" pitchFamily="34" charset="0"/>
+                <a:ea typeface="Arial" pitchFamily="34" charset="-122"/>
+                <a:cs typeface="Arial" pitchFamily="34" charset="-120"/>
+              </a:rPr>
+              <a:t>Written for the three teams who will read this deck without us in the room: compliance, model risk, vendor risk.</a:t>
+            </a:r>
+            <a:endParaRPr lang="en-US" sz="1350" dirty="0"/>
+          </a:p>
+        </p:txBody>
+      </p:sp>
+      <p:pic>
+        <p:nvPicPr>
+          <p:cNvPr id="5" name="Image 0" descr="asset_chain.png">    </p:cNvPr>
+          <p:cNvPicPr>
+            <a:picLocks noChangeAspect="1"/>
+          </p:cNvPicPr>
+          <p:nvPr/>
+        </p:nvPicPr>
+        <p:blipFill>
+          <a:blip r:embed="rId1"/>
+          <a:stretch>
+            <a:fillRect/>
+          </a:stretch>
+        </p:blipFill>
+        <p:spPr>
+          <a:xfrm>
+            <a:off x="594360" y="1874520"/>
+            <a:ext cx="11000232" cy="3849624"/>
+          </a:xfrm>
+          <a:prstGeom prst="rect">
+            <a:avLst/>
+          </a:prstGeom>
+        </p:spPr>
+      </p:pic>
+      <p:sp>
+        <p:nvSpPr>
+          <p:cNvPr id="6" name="Text 3"/>
+          <p:cNvSpPr/>
+          <p:nvPr/>
+        </p:nvSpPr>
+        <p:spPr>
+          <a:xfrm>
+            <a:off x="594360" y="5943600"/>
+            <a:ext cx="10972800" cy="457200"/>
           </a:xfrm>
           <a:prstGeom prst="rect">
             <a:avLst/>
@@ -4214,49 +4382,7 @@
               <a:buNone/>
             </a:pPr>
             <a:r>
-              <a:rPr lang="en-US" sz="1300" b="1" spc="200" kern="0" dirty="0">
-                <a:solidFill>
-                  <a:srgbClr val="12796B"/>
-                </a:solidFill>
-                <a:latin typeface="Arial" pitchFamily="34" charset="0"/>
-                <a:ea typeface="Arial" pitchFamily="34" charset="-122"/>
-                <a:cs typeface="Arial" pitchFamily="34" charset="-120"/>
-              </a:rPr>
-              <a:t>WHAT PUBLISHES</a:t>
-            </a:r>
-            <a:endParaRPr lang="en-US" sz="1300" dirty="0"/>
-          </a:p>
-        </p:txBody>
-      </p:sp>
-      <p:sp>
-        <p:nvSpPr>
-          <p:cNvPr id="5" name="Text 3"/>
-          <p:cNvSpPr/>
-          <p:nvPr/>
-        </p:nvSpPr>
-        <p:spPr>
-          <a:xfrm>
-            <a:off x="594360" y="2176272"/>
-            <a:ext cx="3520440" cy="3291840"/>
-          </a:xfrm>
-          <a:prstGeom prst="rect">
-            <a:avLst/>
-          </a:prstGeom>
-          <a:noFill/>
-          <a:ln/>
-        </p:spPr>
-        <p:txBody>
-          <a:bodyPr wrap="square" lIns="0" tIns="0" rIns="0" bIns="0" rtlCol="0" anchor="t"/>
-          <a:lstStyle/>
-          <a:p>
-            <a:pPr indent="0" marL="0">
-              <a:lnSpc>
-                <a:spcPct val="114000"/>
-              </a:lnSpc>
-              <a:buNone/>
-            </a:pPr>
-            <a:r>
-              <a:rPr lang="en-US" sz="1200" dirty="0">
+              <a:rPr lang="en-US" sz="1450" i="1" dirty="0">
                 <a:solidFill>
                   <a:srgbClr val="0E2726"/>
                 </a:solidFill>
@@ -4264,216 +4390,15 @@
                 <a:ea typeface="Arial" pitchFamily="34" charset="-122"/>
                 <a:cs typeface="Arial" pitchFamily="34" charset="-120"/>
               </a:rPr>
-              <a:t>Ranges and probability distributions. Never a rating, never a price target, never a recommendation. The public site is education only; advice happens inside your perimeter, given by your licensed people.</a:t>
-            </a:r>
-            <a:endParaRPr lang="en-US" sz="1200" dirty="0"/>
-          </a:p>
-        </p:txBody>
-      </p:sp>
-      <p:sp>
-        <p:nvSpPr>
-          <p:cNvPr id="6" name="Text 4"/>
-          <p:cNvSpPr/>
-          <p:nvPr/>
-        </p:nvSpPr>
-        <p:spPr>
-          <a:xfrm>
-            <a:off x="4370832" y="1783080"/>
-            <a:ext cx="3474720" cy="292608"/>
-          </a:xfrm>
-          <a:prstGeom prst="rect">
-            <a:avLst/>
-          </a:prstGeom>
-          <a:noFill/>
-          <a:ln/>
-        </p:spPr>
-        <p:txBody>
-          <a:bodyPr wrap="square" lIns="0" tIns="0" rIns="0" bIns="0" rtlCol="0" anchor="ctr"/>
-          <a:lstStyle/>
-          <a:p>
-            <a:pPr indent="0" marL="0">
-              <a:buNone/>
-            </a:pPr>
-            <a:r>
-              <a:rPr lang="en-US" sz="1300" b="1" spc="200" kern="0" dirty="0">
-                <a:solidFill>
-                  <a:srgbClr val="12796B"/>
-                </a:solidFill>
-                <a:latin typeface="Arial" pitchFamily="34" charset="0"/>
-                <a:ea typeface="Arial" pitchFamily="34" charset="-122"/>
-                <a:cs typeface="Arial" pitchFamily="34" charset="-120"/>
-              </a:rPr>
-              <a:t>WHO SIGNS</a:t>
-            </a:r>
-            <a:endParaRPr lang="en-US" sz="1300" dirty="0"/>
-          </a:p>
-        </p:txBody>
-      </p:sp>
-      <p:sp>
-        <p:nvSpPr>
-          <p:cNvPr id="7" name="Text 5"/>
-          <p:cNvSpPr/>
-          <p:nvPr/>
-        </p:nvSpPr>
-        <p:spPr>
-          <a:xfrm>
-            <a:off x="4370832" y="2176272"/>
-            <a:ext cx="3520440" cy="3291840"/>
-          </a:xfrm>
-          <a:prstGeom prst="rect">
-            <a:avLst/>
-          </a:prstGeom>
-          <a:noFill/>
-          <a:ln/>
-        </p:spPr>
-        <p:txBody>
-          <a:bodyPr wrap="square" lIns="0" tIns="0" rIns="0" bIns="0" rtlCol="0" anchor="t"/>
-          <a:lstStyle/>
-          <a:p>
-            <a:pPr indent="0" marL="0">
-              <a:lnSpc>
-                <a:spcPct val="114000"/>
-              </a:lnSpc>
-              <a:buNone/>
-            </a:pPr>
-            <a:r>
-              <a:rPr lang="en-US" sz="1200" dirty="0">
-                <a:solidFill>
-                  <a:srgbClr val="0E2726"/>
-                </a:solidFill>
-                <a:latin typeface="Arial" pitchFamily="34" charset="0"/>
-                <a:ea typeface="Arial" pitchFamily="34" charset="-122"/>
-                <a:cs typeface="Arial" pitchFamily="34" charset="-120"/>
-              </a:rPr>
-              <a:t>Every published number passes a named human reviewer before release. Under integration that reviewer is your analyst — so the output is your firm’s process, not an outside model’s opinion.</a:t>
-            </a:r>
-            <a:endParaRPr lang="en-US" sz="1200" dirty="0"/>
-          </a:p>
-        </p:txBody>
-      </p:sp>
-      <p:sp>
-        <p:nvSpPr>
-          <p:cNvPr id="8" name="Text 6"/>
-          <p:cNvSpPr/>
-          <p:nvPr/>
-        </p:nvSpPr>
-        <p:spPr>
-          <a:xfrm>
-            <a:off x="8147304" y="1783080"/>
-            <a:ext cx="3474720" cy="292608"/>
-          </a:xfrm>
-          <a:prstGeom prst="rect">
-            <a:avLst/>
-          </a:prstGeom>
-          <a:noFill/>
-          <a:ln/>
-        </p:spPr>
-        <p:txBody>
-          <a:bodyPr wrap="square" lIns="0" tIns="0" rIns="0" bIns="0" rtlCol="0" anchor="ctr"/>
-          <a:lstStyle/>
-          <a:p>
-            <a:pPr indent="0" marL="0">
-              <a:buNone/>
-            </a:pPr>
-            <a:r>
-              <a:rPr lang="en-US" sz="1300" b="1" spc="200" kern="0" dirty="0">
-                <a:solidFill>
-                  <a:srgbClr val="12796B"/>
-                </a:solidFill>
-                <a:latin typeface="Arial" pitchFamily="34" charset="0"/>
-                <a:ea typeface="Arial" pitchFamily="34" charset="-122"/>
-                <a:cs typeface="Arial" pitchFamily="34" charset="-120"/>
-              </a:rPr>
-              <a:t>WHAT YOU CAN AUDIT</a:t>
-            </a:r>
-            <a:endParaRPr lang="en-US" sz="1300" dirty="0"/>
-          </a:p>
-        </p:txBody>
-      </p:sp>
-      <p:sp>
-        <p:nvSpPr>
-          <p:cNvPr id="9" name="Text 7"/>
-          <p:cNvSpPr/>
-          <p:nvPr/>
-        </p:nvSpPr>
-        <p:spPr>
-          <a:xfrm>
-            <a:off x="8147304" y="2176272"/>
-            <a:ext cx="3520440" cy="3291840"/>
-          </a:xfrm>
-          <a:prstGeom prst="rect">
-            <a:avLst/>
-          </a:prstGeom>
-          <a:noFill/>
-          <a:ln/>
-        </p:spPr>
-        <p:txBody>
-          <a:bodyPr wrap="square" lIns="0" tIns="0" rIns="0" bIns="0" rtlCol="0" anchor="t"/>
-          <a:lstStyle/>
-          <a:p>
-            <a:pPr indent="0" marL="0">
-              <a:lnSpc>
-                <a:spcPct val="114000"/>
-              </a:lnSpc>
-              <a:buNone/>
-            </a:pPr>
-            <a:r>
-              <a:rPr lang="en-US" sz="1200" dirty="0">
-                <a:solidFill>
-                  <a:srgbClr val="0E2726"/>
-                </a:solidFill>
-                <a:latin typeface="Arial" pitchFamily="34" charset="0"/>
-                <a:ea typeface="Arial" pitchFamily="34" charset="-122"/>
-                <a:cs typeface="Arial" pitchFamily="34" charset="-120"/>
-              </a:rPr>
-              <a:t>Fixed-seed reproducible runs, full model documentation, every rejected technique named, every forecast time-stamped and graded and never edited. The audit trail exists by construction, not on request.</a:t>
-            </a:r>
-            <a:endParaRPr lang="en-US" sz="1200" dirty="0"/>
-          </a:p>
-        </p:txBody>
-      </p:sp>
-      <p:sp>
-        <p:nvSpPr>
-          <p:cNvPr id="10" name="Text 8"/>
-          <p:cNvSpPr/>
-          <p:nvPr/>
-        </p:nvSpPr>
-        <p:spPr>
-          <a:xfrm>
-            <a:off x="594360" y="5806440"/>
-            <a:ext cx="10972800" cy="640080"/>
-          </a:xfrm>
-          <a:prstGeom prst="rect">
-            <a:avLst/>
-          </a:prstGeom>
-          <a:noFill/>
-          <a:ln/>
-        </p:spPr>
-        <p:txBody>
-          <a:bodyPr wrap="square" lIns="0" tIns="0" rIns="0" bIns="0" rtlCol="0" anchor="t"/>
-          <a:lstStyle/>
-          <a:p>
-            <a:pPr indent="0" marL="0">
-              <a:buNone/>
-            </a:pPr>
-            <a:r>
-              <a:rPr lang="en-US" sz="1400" i="1" dirty="0">
-                <a:solidFill>
-                  <a:srgbClr val="0E2726"/>
-                </a:solidFill>
-                <a:latin typeface="Arial" pitchFamily="34" charset="0"/>
-                <a:ea typeface="Arial" pitchFamily="34" charset="-122"/>
-                <a:cs typeface="Arial" pitchFamily="34" charset="-120"/>
-              </a:rPr>
-              <a:t>Published, time-stamped, graded, misses kept — that’s what honest AI looks like to a regulator. And the pipeline is reproducible by a third party: continuity is a deliverable, not a promise.</a:t>
-            </a:r>
-            <a:endParaRPr lang="en-US" sz="1400" dirty="0"/>
-          </a:p>
-        </p:txBody>
-      </p:sp>
-      <p:sp>
-        <p:nvSpPr>
-          <p:cNvPr id="11" name="Text 9"/>
+              <a:t>Published, time-stamped, graded, misses kept — that’s what honest AI looks like to a regulator. Continuity is a deliverable, not a promise.</a:t>
+            </a:r>
+            <a:endParaRPr lang="en-US" sz="1450" dirty="0"/>
+          </a:p>
+        </p:txBody>
+      </p:sp>
+      <p:sp>
+        <p:nvSpPr>
+          <p:cNvPr id="7" name="Text 4"/>
           <p:cNvSpPr/>
           <p:nvPr/>
         </p:nvSpPr>
@@ -4614,501 +4539,78 @@
                 <a:ea typeface="Arial" pitchFamily="34" charset="-122"/>
                 <a:cs typeface="Arial" pitchFamily="34" charset="-120"/>
               </a:rPr>
-              <a:t>Methodology on one page.</a:t>
+              <a:t>What we built — and what we threw away.</a:t>
             </a:r>
             <a:endParaRPr lang="en-US" sz="3400" dirty="0"/>
           </a:p>
         </p:txBody>
       </p:sp>
-      <p:sp>
-        <p:nvSpPr>
-          <p:cNvPr id="4" name="Text 2"/>
-          <p:cNvSpPr/>
-          <p:nvPr/>
-        </p:nvSpPr>
-        <p:spPr>
-          <a:xfrm>
-            <a:off x="594360" y="1645920"/>
-            <a:ext cx="3474720" cy="292608"/>
-          </a:xfrm>
-          <a:prstGeom prst="rect">
-            <a:avLst/>
-          </a:prstGeom>
-          <a:noFill/>
-          <a:ln/>
-        </p:spPr>
-        <p:txBody>
-          <a:bodyPr wrap="square" lIns="0" tIns="0" rIns="0" bIns="0" rtlCol="0" anchor="ctr"/>
+      <p:pic>
+        <p:nvPicPr>
+          <p:cNvPr id="4" name="Image 0" descr="asset_method.png">    </p:cNvPr>
+          <p:cNvPicPr>
+            <a:picLocks noChangeAspect="1"/>
+          </p:cNvPicPr>
+          <p:nvPr/>
+        </p:nvPicPr>
+        <p:blipFill>
+          <a:blip r:embed="rId1"/>
+          <a:stretch>
+            <a:fillRect/>
+          </a:stretch>
+        </p:blipFill>
+        <p:spPr>
+          <a:xfrm>
+            <a:off x="786384" y="1463040"/>
+            <a:ext cx="10607040" cy="4773168"/>
+          </a:xfrm>
+          <a:prstGeom prst="rect">
+            <a:avLst/>
+          </a:prstGeom>
+        </p:spPr>
+      </p:pic>
+      <p:sp>
+        <p:nvSpPr>
+          <p:cNvPr id="5" name="Text 2"/>
+          <p:cNvSpPr/>
+          <p:nvPr/>
+        </p:nvSpPr>
+        <p:spPr>
+          <a:xfrm>
+            <a:off x="594360" y="6355080"/>
+            <a:ext cx="10881360" cy="365760"/>
+          </a:xfrm>
+          <a:prstGeom prst="rect">
+            <a:avLst/>
+          </a:prstGeom>
+          <a:noFill/>
+          <a:ln/>
+        </p:spPr>
+        <p:txBody>
+          <a:bodyPr wrap="square" lIns="0" tIns="0" rIns="0" bIns="0" rtlCol="0" anchor="t"/>
           <a:lstStyle/>
           <a:p>
             <a:pPr indent="0" marL="0">
               <a:buNone/>
             </a:pPr>
             <a:r>
-              <a:rPr lang="en-US" sz="1250" b="1" spc="150" kern="0" dirty="0">
-                <a:solidFill>
-                  <a:srgbClr val="12796B"/>
-                </a:solidFill>
-                <a:latin typeface="Arial" pitchFamily="34" charset="0"/>
-                <a:ea typeface="Arial" pitchFamily="34" charset="-122"/>
-                <a:cs typeface="Arial" pitchFamily="34" charset="-120"/>
-              </a:rPr>
-              <a:t>THE SIMULATION ENGINE</a:t>
-            </a:r>
-            <a:endParaRPr lang="en-US" sz="1250" dirty="0"/>
-          </a:p>
-        </p:txBody>
-      </p:sp>
-      <p:sp>
-        <p:nvSpPr>
-          <p:cNvPr id="5" name="Text 3"/>
-          <p:cNvSpPr/>
-          <p:nvPr/>
-        </p:nvSpPr>
-        <p:spPr>
-          <a:xfrm>
-            <a:off x="594360" y="2011680"/>
-            <a:ext cx="3566160" cy="3840480"/>
-          </a:xfrm>
-          <a:prstGeom prst="rect">
-            <a:avLst/>
-          </a:prstGeom>
-          <a:noFill/>
-          <a:ln/>
-        </p:spPr>
-        <p:txBody>
-          <a:bodyPr wrap="square" lIns="0" tIns="0" rIns="0" bIns="0" rtlCol="0" anchor="t"/>
-          <a:lstStyle/>
-          <a:p>
-            <a:pPr marL="127000" indent="-127000">
-              <a:lnSpc>
-                <a:spcPct val="108000"/>
-              </a:lnSpc>
-              <a:spcAft>
-                <a:spcPts val="700"/>
-              </a:spcAft>
-              <a:buSzPct val="100000"/>
-              <a:buChar char="•"/>
-            </a:pPr>
-            <a:r>
-              <a:rPr lang="en-US" sz="1050" dirty="0">
-                <a:solidFill>
-                  <a:srgbClr val="0E2726"/>
-                </a:solidFill>
-                <a:latin typeface="Arial" pitchFamily="34" charset="0"/>
-                <a:ea typeface="Arial" pitchFamily="34" charset="-122"/>
-                <a:cs typeface="Arial" pitchFamily="34" charset="-120"/>
-              </a:rPr>
-              <a:t>Carry-anchored YZ-HAR-t Monte Carlo — 50,000 paths per name, fixed seed, calendar 1- and 3-month horizons.</a:t>
+              <a:rPr lang="en-US" sz="1050" i="1" dirty="0">
+                <a:solidFill>
+                  <a:srgbClr val="5C6B70"/>
+                </a:solidFill>
+                <a:latin typeface="Arial" pitchFamily="34" charset="0"/>
+                <a:ea typeface="Arial" pitchFamily="34" charset="-122"/>
+                <a:cs typeface="Arial" pitchFamily="34" charset="-120"/>
+              </a:rPr>
+              <a:t>Testahil publishes fair-value ranges and probability distributions. It does not publish ratings, price targets, or recommendations, and nothing it publishes is investment advice.</a:t>
             </a:r>
             <a:endParaRPr lang="en-US" sz="1050" dirty="0"/>
           </a:p>
-          <a:p>
-            <a:pPr marL="127000" indent="-127000">
-              <a:lnSpc>
-                <a:spcPct val="108000"/>
-              </a:lnSpc>
-              <a:spcAft>
-                <a:spcPts val="700"/>
-              </a:spcAft>
-              <a:buSzPct val="100000"/>
-              <a:buChar char="•"/>
-            </a:pPr>
-            <a:r>
-              <a:rPr lang="en-US" sz="1050" dirty="0">
-                <a:solidFill>
-                  <a:srgbClr val="0E2726"/>
-                </a:solidFill>
-                <a:latin typeface="Arial" pitchFamily="34" charset="0"/>
-                <a:ea typeface="Arial" pitchFamily="34" charset="-122"/>
-                <a:cs typeface="Arial" pitchFamily="34" charset="-120"/>
-              </a:rPr>
-              <a:t>Per-market fitted tail thickness and cone width; Egypt adds a history-gated per-name width overlay.</a:t>
-            </a:r>
-            <a:endParaRPr lang="en-US" sz="1050" dirty="0"/>
-          </a:p>
-          <a:p>
-            <a:pPr marL="127000" indent="-127000">
-              <a:lnSpc>
-                <a:spcPct val="108000"/>
-              </a:lnSpc>
-              <a:spcAft>
-                <a:spcPts val="700"/>
-              </a:spcAft>
-              <a:buSzPct val="100000"/>
-              <a:buChar char="•"/>
-            </a:pPr>
-            <a:r>
-              <a:rPr lang="en-US" sz="1050" dirty="0">
-                <a:solidFill>
-                  <a:srgbClr val="0E2726"/>
-                </a:solidFill>
-                <a:latin typeface="Arial" pitchFamily="34" charset="0"/>
-                <a:ea typeface="Arial" pitchFamily="34" charset="-122"/>
-                <a:cs typeface="Arial" pitchFamily="34" charset="-120"/>
-              </a:rPr>
-              <a:t>Anchored to carry (local risk-free minus yield) — so claimed skill can never secretly be the time value of money.</a:t>
-            </a:r>
-            <a:endParaRPr lang="en-US" sz="1050" dirty="0"/>
-          </a:p>
-        </p:txBody>
-      </p:sp>
-      <p:sp>
-        <p:nvSpPr>
-          <p:cNvPr id="6" name="Text 4"/>
-          <p:cNvSpPr/>
-          <p:nvPr/>
-        </p:nvSpPr>
-        <p:spPr>
-          <a:xfrm>
-            <a:off x="4370832" y="1645920"/>
-            <a:ext cx="3474720" cy="292608"/>
-          </a:xfrm>
-          <a:prstGeom prst="rect">
-            <a:avLst/>
-          </a:prstGeom>
-          <a:noFill/>
-          <a:ln/>
-        </p:spPr>
-        <p:txBody>
-          <a:bodyPr wrap="square" lIns="0" tIns="0" rIns="0" bIns="0" rtlCol="0" anchor="ctr"/>
-          <a:lstStyle/>
-          <a:p>
-            <a:pPr indent="0" marL="0">
-              <a:buNone/>
-            </a:pPr>
-            <a:r>
-              <a:rPr lang="en-US" sz="1250" b="1" spc="150" kern="0" dirty="0">
-                <a:solidFill>
-                  <a:srgbClr val="12796B"/>
-                </a:solidFill>
-                <a:latin typeface="Arial" pitchFamily="34" charset="0"/>
-                <a:ea typeface="Arial" pitchFamily="34" charset="-122"/>
-                <a:cs typeface="Arial" pitchFamily="34" charset="-120"/>
-              </a:rPr>
-              <a:t>THE VALIDATION GATE</a:t>
-            </a:r>
-            <a:endParaRPr lang="en-US" sz="1250" dirty="0"/>
-          </a:p>
-        </p:txBody>
-      </p:sp>
-      <p:sp>
-        <p:nvSpPr>
-          <p:cNvPr id="7" name="Text 5"/>
-          <p:cNvSpPr/>
-          <p:nvPr/>
-        </p:nvSpPr>
-        <p:spPr>
-          <a:xfrm>
-            <a:off x="4370832" y="2011680"/>
-            <a:ext cx="3566160" cy="3840480"/>
-          </a:xfrm>
-          <a:prstGeom prst="rect">
-            <a:avLst/>
-          </a:prstGeom>
-          <a:noFill/>
-          <a:ln/>
-        </p:spPr>
-        <p:txBody>
-          <a:bodyPr wrap="square" lIns="0" tIns="0" rIns="0" bIns="0" rtlCol="0" anchor="t"/>
-          <a:lstStyle/>
-          <a:p>
-            <a:pPr marL="127000" indent="-127000">
-              <a:lnSpc>
-                <a:spcPct val="108000"/>
-              </a:lnSpc>
-              <a:spcAft>
-                <a:spcPts val="700"/>
-              </a:spcAft>
-              <a:buSzPct val="100000"/>
-              <a:buChar char="•"/>
-            </a:pPr>
-            <a:r>
-              <a:rPr lang="en-US" sz="1050" dirty="0">
-                <a:solidFill>
-                  <a:srgbClr val="0E2726"/>
-                </a:solidFill>
-                <a:latin typeface="Arial" pitchFamily="34" charset="0"/>
-                <a:ea typeface="Arial" pitchFamily="34" charset="-122"/>
-                <a:cs typeface="Arial" pitchFamily="34" charset="-120"/>
-              </a:rPr>
-              <a:t>Per-exchange data-quality gate first: price-limit-aware error detection, corporate-action repair.</a:t>
-            </a:r>
-            <a:endParaRPr lang="en-US" sz="1050" dirty="0"/>
-          </a:p>
-          <a:p>
-            <a:pPr marL="127000" indent="-127000">
-              <a:lnSpc>
-                <a:spcPct val="108000"/>
-              </a:lnSpc>
-              <a:spcAft>
-                <a:spcPts val="700"/>
-              </a:spcAft>
-              <a:buSzPct val="100000"/>
-              <a:buChar char="•"/>
-            </a:pPr>
-            <a:r>
-              <a:rPr lang="en-US" sz="1050" dirty="0">
-                <a:solidFill>
-                  <a:srgbClr val="0E2726"/>
-                </a:solidFill>
-                <a:latin typeface="Arial" pitchFamily="34" charset="0"/>
-                <a:ea typeface="Arial" pitchFamily="34" charset="-122"/>
-                <a:cs typeface="Arial" pitchFamily="34" charset="-120"/>
-              </a:rPr>
-              <a:t>Walk-forward, non-overlapping windows, scored against a carry-anchored random-walk benchmark.</a:t>
-            </a:r>
-            <a:endParaRPr lang="en-US" sz="1050" dirty="0"/>
-          </a:p>
-          <a:p>
-            <a:pPr marL="127000" indent="-127000">
-              <a:lnSpc>
-                <a:spcPct val="108000"/>
-              </a:lnSpc>
-              <a:spcAft>
-                <a:spcPts val="700"/>
-              </a:spcAft>
-              <a:buSzPct val="100000"/>
-              <a:buChar char="•"/>
-            </a:pPr>
-            <a:r>
-              <a:rPr lang="en-US" sz="1050" dirty="0">
-                <a:solidFill>
-                  <a:srgbClr val="0E2726"/>
-                </a:solidFill>
-                <a:latin typeface="Arial" pitchFamily="34" charset="0"/>
-                <a:ea typeface="Arial" pitchFamily="34" charset="-122"/>
-                <a:cs typeface="Arial" pitchFamily="34" charset="-120"/>
-              </a:rPr>
-              <a:t>Verdicts published per name and per market: PASS / PARITY / FAIL — one statistically robust name-level FAIL is on the record today.</a:t>
-            </a:r>
-            <a:endParaRPr lang="en-US" sz="1050" dirty="0"/>
-          </a:p>
-          <a:p>
-            <a:pPr marL="127000" indent="-127000">
-              <a:lnSpc>
-                <a:spcPct val="108000"/>
-              </a:lnSpc>
-              <a:spcAft>
-                <a:spcPts val="700"/>
-              </a:spcAft>
-              <a:buSzPct val="100000"/>
-              <a:buChar char="•"/>
-            </a:pPr>
-            <a:r>
-              <a:rPr lang="en-US" sz="1050" dirty="0">
-                <a:solidFill>
-                  <a:srgbClr val="0E2726"/>
-                </a:solidFill>
-                <a:latin typeface="Arial" pitchFamily="34" charset="0"/>
-                <a:ea typeface="Arial" pitchFamily="34" charset="-122"/>
-                <a:cs typeface="Arial" pitchFamily="34" charset="-120"/>
-              </a:rPr>
-              <a:t>Tested and rejected on the way: CRPS-tuned selection, raw &amp; trend drift, fair-value pull, dynamic tail thickness, HARQ / skew-t, per-stock drift &amp; width, pairwise ratio reversion.</a:t>
-            </a:r>
-            <a:endParaRPr lang="en-US" sz="1050" dirty="0"/>
-          </a:p>
-        </p:txBody>
-      </p:sp>
-      <p:sp>
-        <p:nvSpPr>
-          <p:cNvPr id="8" name="Text 6"/>
-          <p:cNvSpPr/>
-          <p:nvPr/>
-        </p:nvSpPr>
-        <p:spPr>
-          <a:xfrm>
-            <a:off x="8147304" y="1645920"/>
-            <a:ext cx="3474720" cy="292608"/>
-          </a:xfrm>
-          <a:prstGeom prst="rect">
-            <a:avLst/>
-          </a:prstGeom>
-          <a:noFill/>
-          <a:ln/>
-        </p:spPr>
-        <p:txBody>
-          <a:bodyPr wrap="square" lIns="0" tIns="0" rIns="0" bIns="0" rtlCol="0" anchor="ctr"/>
-          <a:lstStyle/>
-          <a:p>
-            <a:pPr indent="0" marL="0">
-              <a:buNone/>
-            </a:pPr>
-            <a:r>
-              <a:rPr lang="en-US" sz="1250" b="1" spc="150" kern="0" dirty="0">
-                <a:solidFill>
-                  <a:srgbClr val="12796B"/>
-                </a:solidFill>
-                <a:latin typeface="Arial" pitchFamily="34" charset="0"/>
-                <a:ea typeface="Arial" pitchFamily="34" charset="-122"/>
-                <a:cs typeface="Arial" pitchFamily="34" charset="-120"/>
-              </a:rPr>
-              <a:t>THE FUNDAMENTAL STUDIES</a:t>
-            </a:r>
-            <a:endParaRPr lang="en-US" sz="1250" dirty="0"/>
-          </a:p>
-        </p:txBody>
-      </p:sp>
-      <p:sp>
-        <p:nvSpPr>
-          <p:cNvPr id="9" name="Text 7"/>
-          <p:cNvSpPr/>
-          <p:nvPr/>
-        </p:nvSpPr>
-        <p:spPr>
-          <a:xfrm>
-            <a:off x="8147304" y="2011680"/>
-            <a:ext cx="3566160" cy="3840480"/>
-          </a:xfrm>
-          <a:prstGeom prst="rect">
-            <a:avLst/>
-          </a:prstGeom>
-          <a:noFill/>
-          <a:ln/>
-        </p:spPr>
-        <p:txBody>
-          <a:bodyPr wrap="square" lIns="0" tIns="0" rIns="0" bIns="0" rtlCol="0" anchor="t"/>
-          <a:lstStyle/>
-          <a:p>
-            <a:pPr marL="127000" indent="-127000">
-              <a:lnSpc>
-                <a:spcPct val="108000"/>
-              </a:lnSpc>
-              <a:spcAft>
-                <a:spcPts val="700"/>
-              </a:spcAft>
-              <a:buSzPct val="100000"/>
-              <a:buChar char="•"/>
-            </a:pPr>
-            <a:r>
-              <a:rPr lang="en-US" sz="1050" dirty="0">
-                <a:solidFill>
-                  <a:srgbClr val="0E2726"/>
-                </a:solidFill>
-                <a:latin typeface="Arial" pitchFamily="34" charset="0"/>
-                <a:ea typeface="Arial" pitchFamily="34" charset="-122"/>
-                <a:cs typeface="Arial" pitchFamily="34" charset="-120"/>
-              </a:rPr>
-              <a:t>Built only from official company filings — no data vendors, no broker estimates, ever.</a:t>
-            </a:r>
-            <a:endParaRPr lang="en-US" sz="1050" dirty="0"/>
-          </a:p>
-          <a:p>
-            <a:pPr marL="127000" indent="-127000">
-              <a:lnSpc>
-                <a:spcPct val="108000"/>
-              </a:lnSpc>
-              <a:spcAft>
-                <a:spcPts val="700"/>
-              </a:spcAft>
-              <a:buSzPct val="100000"/>
-              <a:buChar char="•"/>
-            </a:pPr>
-            <a:r>
-              <a:rPr lang="en-US" sz="1050" dirty="0">
-                <a:solidFill>
-                  <a:srgbClr val="0E2726"/>
-                </a:solidFill>
-                <a:latin typeface="Arial" pitchFamily="34" charset="0"/>
-                <a:ea typeface="Arial" pitchFamily="34" charset="-122"/>
-                <a:cs typeface="Arial" pitchFamily="34" charset="-120"/>
-              </a:rPr>
-              <a:t>Ground-up: product by product, volume × price, cost per unit — growth projected in both volume and price.</a:t>
-            </a:r>
-            <a:endParaRPr lang="en-US" sz="1050" dirty="0"/>
-          </a:p>
-          <a:p>
-            <a:pPr marL="127000" indent="-127000">
-              <a:lnSpc>
-                <a:spcPct val="108000"/>
-              </a:lnSpc>
-              <a:spcAft>
-                <a:spcPts val="700"/>
-              </a:spcAft>
-              <a:buSzPct val="100000"/>
-              <a:buChar char="•"/>
-            </a:pPr>
-            <a:r>
-              <a:rPr lang="en-US" sz="1050" dirty="0">
-                <a:solidFill>
-                  <a:srgbClr val="0E2726"/>
-                </a:solidFill>
-                <a:latin typeface="Arial" pitchFamily="34" charset="0"/>
-                <a:ea typeface="Arial" pitchFamily="34" charset="-122"/>
-                <a:cs typeface="Arial" pitchFamily="34" charset="-120"/>
-              </a:rPr>
-              <a:t>Full live-formula chain: drivers → IS → BS → CF → DCF; debt split local vs foreign currency; working capital projected, not plugged.</a:t>
-            </a:r>
-            <a:endParaRPr lang="en-US" sz="1050" dirty="0"/>
-          </a:p>
-          <a:p>
-            <a:pPr marL="127000" indent="-127000">
-              <a:lnSpc>
-                <a:spcPct val="108000"/>
-              </a:lnSpc>
-              <a:spcAft>
-                <a:spcPts val="700"/>
-              </a:spcAft>
-              <a:buSzPct val="100000"/>
-              <a:buChar char="•"/>
-            </a:pPr>
-            <a:r>
-              <a:rPr lang="en-US" sz="1050" dirty="0">
-                <a:solidFill>
-                  <a:srgbClr val="0E2726"/>
-                </a:solidFill>
-                <a:latin typeface="Arial" pitchFamily="34" charset="0"/>
-                <a:ea typeface="Arial" pitchFamily="34" charset="-122"/>
-                <a:cs typeface="Arial" pitchFamily="34" charset="-120"/>
-              </a:rPr>
-              <a:t>Beta regressed on the published index of the stock’s own exchange — never a home-made composite.</a:t>
-            </a:r>
-            <a:endParaRPr lang="en-US" sz="1050" dirty="0"/>
-          </a:p>
-        </p:txBody>
-      </p:sp>
-      <p:sp>
-        <p:nvSpPr>
-          <p:cNvPr id="10" name="Text 8"/>
-          <p:cNvSpPr/>
-          <p:nvPr/>
-        </p:nvSpPr>
-        <p:spPr>
-          <a:xfrm>
-            <a:off x="594360" y="6053328"/>
-            <a:ext cx="10972800" cy="457200"/>
-          </a:xfrm>
-          <a:prstGeom prst="rect">
-            <a:avLst/>
-          </a:prstGeom>
-          <a:noFill/>
-          <a:ln/>
-        </p:spPr>
-        <p:txBody>
-          <a:bodyPr wrap="square" lIns="0" tIns="0" rIns="0" bIns="0" rtlCol="0" anchor="t"/>
-          <a:lstStyle/>
-          <a:p>
-            <a:pPr indent="0" marL="0">
-              <a:buNone/>
-            </a:pPr>
-            <a:r>
-              <a:rPr lang="en-US" sz="1150" i="1" dirty="0">
-                <a:solidFill>
-                  <a:srgbClr val="5C6B70"/>
-                </a:solidFill>
-                <a:latin typeface="Arial" pitchFamily="34" charset="0"/>
-                <a:ea typeface="Arial" pitchFamily="34" charset="-122"/>
-                <a:cs typeface="Arial" pitchFamily="34" charset="-120"/>
-              </a:rPr>
-              <a:t>Testahil publishes fair-value ranges and probability distributions. It does not publish ratings, price targets, or recommendations, and nothing it publishes is investment advice.</a:t>
-            </a:r>
-            <a:endParaRPr lang="en-US" sz="1150" dirty="0"/>
-          </a:p>
-        </p:txBody>
-      </p:sp>
-      <p:sp>
-        <p:nvSpPr>
-          <p:cNvPr id="11" name="Text 9"/>
+        </p:txBody>
+      </p:sp>
+      <p:sp>
+        <p:nvSpPr>
+          <p:cNvPr id="6" name="Text 3"/>
           <p:cNvSpPr/>
           <p:nvPr/>
         </p:nvSpPr>
@@ -9779,8 +9281,194 @@
         </p:nvSpPr>
         <p:spPr>
           <a:xfrm>
-            <a:off x="594360" y="1783080"/>
-            <a:ext cx="3474720" cy="292608"/>
+            <a:off x="4343400" y="1810512"/>
+            <a:ext cx="2331720" cy="777240"/>
+          </a:xfrm>
+          <a:prstGeom prst="rect">
+            <a:avLst/>
+          </a:prstGeom>
+          <a:noFill/>
+          <a:ln/>
+        </p:spPr>
+        <p:txBody>
+          <a:bodyPr wrap="square" lIns="0" tIns="0" rIns="0" bIns="0" rtlCol="0" anchor="b"/>
+          <a:lstStyle/>
+          <a:p>
+            <a:pPr algn="ctr" indent="0" marL="0">
+              <a:lnSpc>
+                <a:spcPct val="105000"/>
+              </a:lnSpc>
+              <a:buNone/>
+            </a:pPr>
+            <a:r>
+              <a:rPr lang="en-US" sz="1050" b="1" dirty="0">
+                <a:solidFill>
+                  <a:srgbClr val="5C6B70"/>
+                </a:solidFill>
+                <a:latin typeface="Arial" pitchFamily="34" charset="0"/>
+                <a:ea typeface="Arial" pitchFamily="34" charset="-122"/>
+                <a:cs typeface="Arial" pitchFamily="34" charset="-120"/>
+              </a:rPr>
+              <a:t>Covers the EGX·ADX·Tadawul</a:t>
+            </a:r>
+            <a:endParaRPr lang="en-US" sz="1050" dirty="0"/>
+          </a:p>
+          <a:p>
+            <a:pPr algn="ctr" indent="0" marL="0">
+              <a:lnSpc>
+                <a:spcPct val="105000"/>
+              </a:lnSpc>
+              <a:buNone/>
+            </a:pPr>
+            <a:r>
+              <a:rPr lang="en-US" sz="1050" b="1" dirty="0">
+                <a:solidFill>
+                  <a:srgbClr val="5C6B70"/>
+                </a:solidFill>
+                <a:latin typeface="Arial" pitchFamily="34" charset="0"/>
+                <a:ea typeface="Arial" pitchFamily="34" charset="-122"/>
+                <a:cs typeface="Arial" pitchFamily="34" charset="-120"/>
+              </a:rPr>
+              <a:t>long tail, from filings</a:t>
+            </a:r>
+            <a:endParaRPr lang="en-US" sz="1050" dirty="0"/>
+          </a:p>
+        </p:txBody>
+      </p:sp>
+      <p:sp>
+        <p:nvSpPr>
+          <p:cNvPr id="5" name="Text 3"/>
+          <p:cNvSpPr/>
+          <p:nvPr/>
+        </p:nvSpPr>
+        <p:spPr>
+          <a:xfrm>
+            <a:off x="6858000" y="1810512"/>
+            <a:ext cx="2331720" cy="777240"/>
+          </a:xfrm>
+          <a:prstGeom prst="rect">
+            <a:avLst/>
+          </a:prstGeom>
+          <a:noFill/>
+          <a:ln/>
+        </p:spPr>
+        <p:txBody>
+          <a:bodyPr wrap="square" lIns="0" tIns="0" rIns="0" bIns="0" rtlCol="0" anchor="b"/>
+          <a:lstStyle/>
+          <a:p>
+            <a:pPr algn="ctr" indent="0" marL="0">
+              <a:lnSpc>
+                <a:spcPct val="105000"/>
+              </a:lnSpc>
+              <a:buNone/>
+            </a:pPr>
+            <a:r>
+              <a:rPr lang="en-US" sz="1050" b="1" dirty="0">
+                <a:solidFill>
+                  <a:srgbClr val="5C6B70"/>
+                </a:solidFill>
+                <a:latin typeface="Arial" pitchFamily="34" charset="0"/>
+                <a:ea typeface="Arial" pitchFamily="34" charset="-122"/>
+                <a:cs typeface="Arial" pitchFamily="34" charset="-120"/>
+              </a:rPr>
+              <a:t>A public record,</a:t>
+            </a:r>
+            <a:endParaRPr lang="en-US" sz="1050" dirty="0"/>
+          </a:p>
+          <a:p>
+            <a:pPr algn="ctr" indent="0" marL="0">
+              <a:lnSpc>
+                <a:spcPct val="105000"/>
+              </a:lnSpc>
+              <a:buNone/>
+            </a:pPr>
+            <a:r>
+              <a:rPr lang="en-US" sz="1050" b="1" dirty="0">
+                <a:solidFill>
+                  <a:srgbClr val="5C6B70"/>
+                </a:solidFill>
+                <a:latin typeface="Arial" pitchFamily="34" charset="0"/>
+                <a:ea typeface="Arial" pitchFamily="34" charset="-122"/>
+                <a:cs typeface="Arial" pitchFamily="34" charset="-120"/>
+              </a:rPr>
+              <a:t>misses kept</a:t>
+            </a:r>
+            <a:endParaRPr lang="en-US" sz="1050" dirty="0"/>
+          </a:p>
+        </p:txBody>
+      </p:sp>
+      <p:sp>
+        <p:nvSpPr>
+          <p:cNvPr id="6" name="Text 4"/>
+          <p:cNvSpPr/>
+          <p:nvPr/>
+        </p:nvSpPr>
+        <p:spPr>
+          <a:xfrm>
+            <a:off x="9372600" y="1810512"/>
+            <a:ext cx="2331720" cy="777240"/>
+          </a:xfrm>
+          <a:prstGeom prst="rect">
+            <a:avLst/>
+          </a:prstGeom>
+          <a:noFill/>
+          <a:ln/>
+        </p:spPr>
+        <p:txBody>
+          <a:bodyPr wrap="square" lIns="0" tIns="0" rIns="0" bIns="0" rtlCol="0" anchor="b"/>
+          <a:lstStyle/>
+          <a:p>
+            <a:pPr algn="ctr" indent="0" marL="0">
+              <a:lnSpc>
+                <a:spcPct val="105000"/>
+              </a:lnSpc>
+              <a:buNone/>
+            </a:pPr>
+            <a:r>
+              <a:rPr lang="en-US" sz="1050" b="1" dirty="0">
+                <a:solidFill>
+                  <a:srgbClr val="5C6B70"/>
+                </a:solidFill>
+                <a:latin typeface="Arial" pitchFamily="34" charset="0"/>
+                <a:ea typeface="Arial" pitchFamily="34" charset="-122"/>
+                <a:cs typeface="Arial" pitchFamily="34" charset="-120"/>
+              </a:rPr>
+              <a:t>Live for your</a:t>
+            </a:r>
+            <a:endParaRPr lang="en-US" sz="1050" dirty="0"/>
+          </a:p>
+          <a:p>
+            <a:pPr algn="ctr" indent="0" marL="0">
+              <a:lnSpc>
+                <a:spcPct val="105000"/>
+              </a:lnSpc>
+              <a:buNone/>
+            </a:pPr>
+            <a:r>
+              <a:rPr lang="en-US" sz="1050" b="1" dirty="0">
+                <a:solidFill>
+                  <a:srgbClr val="5C6B70"/>
+                </a:solidFill>
+                <a:latin typeface="Arial" pitchFamily="34" charset="0"/>
+                <a:ea typeface="Arial" pitchFamily="34" charset="-122"/>
+                <a:cs typeface="Arial" pitchFamily="34" charset="-120"/>
+              </a:rPr>
+              <a:t>clients today</a:t>
+            </a:r>
+            <a:endParaRPr lang="en-US" sz="1050" dirty="0"/>
+          </a:p>
+        </p:txBody>
+      </p:sp>
+      <p:sp>
+        <p:nvSpPr>
+          <p:cNvPr id="7" name="Text 5"/>
+          <p:cNvSpPr/>
+          <p:nvPr/>
+        </p:nvSpPr>
+        <p:spPr>
+          <a:xfrm>
+            <a:off x="594360" y="2743200"/>
+            <a:ext cx="3566160" cy="310896"/>
           </a:xfrm>
           <a:prstGeom prst="rect">
             <a:avLst/>
@@ -9796,49 +9484,283 @@
               <a:buNone/>
             </a:pPr>
             <a:r>
-              <a:rPr lang="en-US" sz="1300" b="1" spc="200" kern="0" dirty="0">
-                <a:solidFill>
-                  <a:srgbClr val="12796B"/>
-                </a:solidFill>
-                <a:latin typeface="Arial" pitchFamily="34" charset="0"/>
-                <a:ea typeface="Arial" pitchFamily="34" charset="-122"/>
-                <a:cs typeface="Arial" pitchFamily="34" charset="-120"/>
-              </a:rPr>
-              <a:t>THE GLOBAL VENDORS</a:t>
-            </a:r>
-            <a:endParaRPr lang="en-US" sz="1300" dirty="0"/>
-          </a:p>
-        </p:txBody>
-      </p:sp>
-      <p:sp>
-        <p:nvSpPr>
-          <p:cNvPr id="5" name="Text 3"/>
-          <p:cNvSpPr/>
-          <p:nvPr/>
-        </p:nvSpPr>
-        <p:spPr>
-          <a:xfrm>
-            <a:off x="594360" y="2176272"/>
-            <a:ext cx="3520440" cy="3383280"/>
-          </a:xfrm>
-          <a:prstGeom prst="rect">
-            <a:avLst/>
-          </a:prstGeom>
-          <a:noFill/>
-          <a:ln/>
-        </p:spPr>
-        <p:txBody>
-          <a:bodyPr wrap="square" lIns="0" tIns="0" rIns="0" bIns="0" rtlCol="0" anchor="t"/>
+              <a:rPr lang="en-US" sz="1450" b="1" dirty="0">
+                <a:solidFill>
+                  <a:srgbClr val="0E2726"/>
+                </a:solidFill>
+                <a:latin typeface="Arial" pitchFamily="34" charset="0"/>
+                <a:ea typeface="Arial" pitchFamily="34" charset="-122"/>
+                <a:cs typeface="Arial" pitchFamily="34" charset="-120"/>
+              </a:rPr>
+              <a:t>Global vendors</a:t>
+            </a:r>
+            <a:endParaRPr lang="en-US" sz="1450" dirty="0"/>
+          </a:p>
+        </p:txBody>
+      </p:sp>
+      <p:sp>
+        <p:nvSpPr>
+          <p:cNvPr id="8" name="Text 6"/>
+          <p:cNvSpPr/>
+          <p:nvPr/>
+        </p:nvSpPr>
+        <p:spPr>
+          <a:xfrm>
+            <a:off x="594360" y="3072384"/>
+            <a:ext cx="3566160" cy="274320"/>
+          </a:xfrm>
+          <a:prstGeom prst="rect">
+            <a:avLst/>
+          </a:prstGeom>
+          <a:noFill/>
+          <a:ln/>
+        </p:spPr>
+        <p:txBody>
+          <a:bodyPr wrap="square" lIns="0" tIns="0" rIns="0" bIns="0" rtlCol="0" anchor="ctr"/>
           <a:lstStyle/>
           <a:p>
             <a:pPr indent="0" marL="0">
-              <a:lnSpc>
-                <a:spcPct val="114000"/>
-              </a:lnSpc>
-              <a:buNone/>
-            </a:pPr>
-            <a:r>
-              <a:rPr lang="en-US" sz="1200" dirty="0">
+              <a:buNone/>
+            </a:pPr>
+            <a:r>
+              <a:rPr lang="en-US" sz="950" i="1" dirty="0">
+                <a:solidFill>
+                  <a:srgbClr val="7A8A86"/>
+                </a:solidFill>
+                <a:latin typeface="Arial" pitchFamily="34" charset="0"/>
+                <a:ea typeface="Arial" pitchFamily="34" charset="-122"/>
+                <a:cs typeface="Arial" pitchFamily="34" charset="-120"/>
+              </a:rPr>
+              <a:t>Trading Central, Morningstar &amp; peers</a:t>
+            </a:r>
+            <a:endParaRPr lang="en-US" sz="950" dirty="0"/>
+          </a:p>
+        </p:txBody>
+      </p:sp>
+      <p:sp>
+        <p:nvSpPr>
+          <p:cNvPr id="9" name="Shape 7"/>
+          <p:cNvSpPr/>
+          <p:nvPr/>
+        </p:nvSpPr>
+        <p:spPr>
+          <a:xfrm>
+            <a:off x="4480560" y="2834640"/>
+            <a:ext cx="2057400" cy="411480"/>
+          </a:xfrm>
+          <a:prstGeom prst="roundRect">
+            <a:avLst>
+              <a:gd name="adj" fmla="val 48889"/>
+            </a:avLst>
+          </a:prstGeom>
+          <a:solidFill>
+            <a:srgbClr val="E4E9E7"/>
+          </a:solidFill>
+          <a:ln w="12700">
+            <a:solidFill>
+              <a:srgbClr val="D5DDDA"/>
+            </a:solidFill>
+            <a:prstDash val="solid"/>
+          </a:ln>
+        </p:spPr>
+      </p:sp>
+      <p:sp>
+        <p:nvSpPr>
+          <p:cNvPr id="10" name="Text 8"/>
+          <p:cNvSpPr/>
+          <p:nvPr/>
+        </p:nvSpPr>
+        <p:spPr>
+          <a:xfrm>
+            <a:off x="4480560" y="2834640"/>
+            <a:ext cx="2057400" cy="411480"/>
+          </a:xfrm>
+          <a:prstGeom prst="rect">
+            <a:avLst/>
+          </a:prstGeom>
+          <a:noFill/>
+          <a:ln/>
+        </p:spPr>
+        <p:txBody>
+          <a:bodyPr wrap="square" lIns="0" tIns="0" rIns="0" bIns="0" rtlCol="0" anchor="ctr"/>
+          <a:lstStyle/>
+          <a:p>
+            <a:pPr algn="ctr" indent="0" marL="0">
+              <a:buNone/>
+            </a:pPr>
+            <a:r>
+              <a:rPr lang="en-US" sz="1150" b="1" spc="100" kern="0" dirty="0">
+                <a:solidFill>
+                  <a:srgbClr val="5C6B70"/>
+                </a:solidFill>
+                <a:latin typeface="Arial" pitchFamily="34" charset="0"/>
+                <a:ea typeface="Arial" pitchFamily="34" charset="-122"/>
+                <a:cs typeface="Arial" pitchFamily="34" charset="-120"/>
+              </a:rPr>
+              <a:t>NO</a:t>
+            </a:r>
+            <a:endParaRPr lang="en-US" sz="1150" dirty="0"/>
+          </a:p>
+        </p:txBody>
+      </p:sp>
+      <p:sp>
+        <p:nvSpPr>
+          <p:cNvPr id="11" name="Shape 9"/>
+          <p:cNvSpPr/>
+          <p:nvPr/>
+        </p:nvSpPr>
+        <p:spPr>
+          <a:xfrm>
+            <a:off x="6995160" y="2834640"/>
+            <a:ext cx="2057400" cy="411480"/>
+          </a:xfrm>
+          <a:prstGeom prst="roundRect">
+            <a:avLst>
+              <a:gd name="adj" fmla="val 48889"/>
+            </a:avLst>
+          </a:prstGeom>
+          <a:solidFill>
+            <a:srgbClr val="E4E9E7"/>
+          </a:solidFill>
+          <a:ln w="12700">
+            <a:solidFill>
+              <a:srgbClr val="D5DDDA"/>
+            </a:solidFill>
+            <a:prstDash val="solid"/>
+          </a:ln>
+        </p:spPr>
+      </p:sp>
+      <p:sp>
+        <p:nvSpPr>
+          <p:cNvPr id="12" name="Text 10"/>
+          <p:cNvSpPr/>
+          <p:nvPr/>
+        </p:nvSpPr>
+        <p:spPr>
+          <a:xfrm>
+            <a:off x="6995160" y="2834640"/>
+            <a:ext cx="2057400" cy="411480"/>
+          </a:xfrm>
+          <a:prstGeom prst="rect">
+            <a:avLst/>
+          </a:prstGeom>
+          <a:noFill/>
+          <a:ln/>
+        </p:spPr>
+        <p:txBody>
+          <a:bodyPr wrap="square" lIns="0" tIns="0" rIns="0" bIns="0" rtlCol="0" anchor="ctr"/>
+          <a:lstStyle/>
+          <a:p>
+            <a:pPr algn="ctr" indent="0" marL="0">
+              <a:buNone/>
+            </a:pPr>
+            <a:r>
+              <a:rPr lang="en-US" sz="1150" b="1" spc="100" kern="0" dirty="0">
+                <a:solidFill>
+                  <a:srgbClr val="5C6B70"/>
+                </a:solidFill>
+                <a:latin typeface="Arial" pitchFamily="34" charset="0"/>
+                <a:ea typeface="Arial" pitchFamily="34" charset="-122"/>
+                <a:cs typeface="Arial" pitchFamily="34" charset="-120"/>
+              </a:rPr>
+              <a:t>NO</a:t>
+            </a:r>
+            <a:endParaRPr lang="en-US" sz="1150" dirty="0"/>
+          </a:p>
+        </p:txBody>
+      </p:sp>
+      <p:sp>
+        <p:nvSpPr>
+          <p:cNvPr id="13" name="Shape 11"/>
+          <p:cNvSpPr/>
+          <p:nvPr/>
+        </p:nvSpPr>
+        <p:spPr>
+          <a:xfrm>
+            <a:off x="9509760" y="2834640"/>
+            <a:ext cx="2057400" cy="411480"/>
+          </a:xfrm>
+          <a:prstGeom prst="roundRect">
+            <a:avLst>
+              <a:gd name="adj" fmla="val 48889"/>
+            </a:avLst>
+          </a:prstGeom>
+          <a:solidFill>
+            <a:srgbClr val="E4E9E7"/>
+          </a:solidFill>
+          <a:ln w="12700">
+            <a:solidFill>
+              <a:srgbClr val="D5DDDA"/>
+            </a:solidFill>
+            <a:prstDash val="solid"/>
+          </a:ln>
+        </p:spPr>
+      </p:sp>
+      <p:sp>
+        <p:nvSpPr>
+          <p:cNvPr id="14" name="Text 12"/>
+          <p:cNvSpPr/>
+          <p:nvPr/>
+        </p:nvSpPr>
+        <p:spPr>
+          <a:xfrm>
+            <a:off x="9509760" y="2834640"/>
+            <a:ext cx="2057400" cy="411480"/>
+          </a:xfrm>
+          <a:prstGeom prst="rect">
+            <a:avLst/>
+          </a:prstGeom>
+          <a:noFill/>
+          <a:ln/>
+        </p:spPr>
+        <p:txBody>
+          <a:bodyPr wrap="square" lIns="0" tIns="0" rIns="0" bIns="0" rtlCol="0" anchor="ctr"/>
+          <a:lstStyle/>
+          <a:p>
+            <a:pPr algn="ctr" indent="0" marL="0">
+              <a:buNone/>
+            </a:pPr>
+            <a:r>
+              <a:rPr lang="en-US" sz="1150" b="1" spc="100" kern="0" dirty="0">
+                <a:solidFill>
+                  <a:srgbClr val="5C6B70"/>
+                </a:solidFill>
+                <a:latin typeface="Arial" pitchFamily="34" charset="0"/>
+                <a:ea typeface="Arial" pitchFamily="34" charset="-122"/>
+                <a:cs typeface="Arial" pitchFamily="34" charset="-120"/>
+              </a:rPr>
+              <a:t>NOT HERE</a:t>
+            </a:r>
+            <a:endParaRPr lang="en-US" sz="1150" dirty="0"/>
+          </a:p>
+        </p:txBody>
+      </p:sp>
+      <p:sp>
+        <p:nvSpPr>
+          <p:cNvPr id="15" name="Text 13"/>
+          <p:cNvSpPr/>
+          <p:nvPr/>
+        </p:nvSpPr>
+        <p:spPr>
+          <a:xfrm>
+            <a:off x="594360" y="3566160"/>
+            <a:ext cx="3566160" cy="310896"/>
+          </a:xfrm>
+          <a:prstGeom prst="rect">
+            <a:avLst/>
+          </a:prstGeom>
+          <a:noFill/>
+          <a:ln/>
+        </p:spPr>
+        <p:txBody>
+          <a:bodyPr wrap="square" lIns="0" tIns="0" rIns="0" bIns="0" rtlCol="0" anchor="ctr"/>
+          <a:lstStyle/>
+          <a:p>
+            <a:pPr indent="0" marL="0">
+              <a:buNone/>
+            </a:pPr>
+            <a:r>
+              <a:rPr lang="en-US" sz="1450" b="1" dirty="0">
                 <a:solidFill>
                   <a:srgbClr val="0E2726"/>
                 </a:solidFill>
@@ -9846,22 +9768,22 @@
                 <a:ea typeface="Arial" pitchFamily="34" charset="-122"/>
                 <a:cs typeface="Arial" pitchFamily="34" charset="-120"/>
               </a:rPr>
-              <a:t>Trading Central, Morningstar and peers already sell analytics into brokers — which proves the category rather than closing it. Their emphasis is developed-market equities, FX, indices, commodities, built from vendor feeds. EGX, ADX and Tadawul small and mid caps, rebuilt from the companies’ own filings, is the part they do not reach.</a:t>
-            </a:r>
-            <a:endParaRPr lang="en-US" sz="1200" dirty="0"/>
-          </a:p>
-        </p:txBody>
-      </p:sp>
-      <p:sp>
-        <p:nvSpPr>
-          <p:cNvPr id="6" name="Text 4"/>
-          <p:cNvSpPr/>
-          <p:nvPr/>
-        </p:nvSpPr>
-        <p:spPr>
-          <a:xfrm>
-            <a:off x="4370832" y="1783080"/>
-            <a:ext cx="3474720" cy="292608"/>
+              <a:t>Build it in-house</a:t>
+            </a:r>
+            <a:endParaRPr lang="en-US" sz="1450" dirty="0"/>
+          </a:p>
+        </p:txBody>
+      </p:sp>
+      <p:sp>
+        <p:nvSpPr>
+          <p:cNvPr id="16" name="Text 14"/>
+          <p:cNvSpPr/>
+          <p:nvPr/>
+        </p:nvSpPr>
+        <p:spPr>
+          <a:xfrm>
+            <a:off x="594360" y="3895344"/>
+            <a:ext cx="3566160" cy="274320"/>
           </a:xfrm>
           <a:prstGeom prst="rect">
             <a:avLst/>
@@ -9877,49 +9799,244 @@
               <a:buNone/>
             </a:pPr>
             <a:r>
-              <a:rPr lang="en-US" sz="1300" b="1" spc="200" kern="0" dirty="0">
-                <a:solidFill>
-                  <a:srgbClr val="12796B"/>
-                </a:solidFill>
-                <a:latin typeface="Arial" pitchFamily="34" charset="0"/>
-                <a:ea typeface="Arial" pitchFamily="34" charset="-122"/>
-                <a:cs typeface="Arial" pitchFamily="34" charset="-120"/>
-              </a:rPr>
-              <a:t>BUILD IT IN-HOUSE</a:t>
-            </a:r>
-            <a:endParaRPr lang="en-US" sz="1300" dirty="0"/>
-          </a:p>
-        </p:txBody>
-      </p:sp>
-      <p:sp>
-        <p:nvSpPr>
-          <p:cNvPr id="7" name="Text 5"/>
-          <p:cNvSpPr/>
-          <p:nvPr/>
-        </p:nvSpPr>
-        <p:spPr>
-          <a:xfrm>
-            <a:off x="4370832" y="2176272"/>
-            <a:ext cx="3520440" cy="3383280"/>
-          </a:xfrm>
-          <a:prstGeom prst="rect">
-            <a:avLst/>
-          </a:prstGeom>
-          <a:noFill/>
-          <a:ln/>
-        </p:spPr>
-        <p:txBody>
-          <a:bodyPr wrap="square" lIns="0" tIns="0" rIns="0" bIns="0" rtlCol="0" anchor="t"/>
+              <a:rPr lang="en-US" sz="950" i="1" dirty="0">
+                <a:solidFill>
+                  <a:srgbClr val="7A8A86"/>
+                </a:solidFill>
+                <a:latin typeface="Arial" pitchFamily="34" charset="0"/>
+                <a:ea typeface="Arial" pitchFamily="34" charset="-122"/>
+                <a:cs typeface="Arial" pitchFamily="34" charset="-120"/>
+              </a:rPr>
+              <a:t>a capable quant desk</a:t>
+            </a:r>
+            <a:endParaRPr lang="en-US" sz="950" dirty="0"/>
+          </a:p>
+        </p:txBody>
+      </p:sp>
+      <p:sp>
+        <p:nvSpPr>
+          <p:cNvPr id="17" name="Shape 15"/>
+          <p:cNvSpPr/>
+          <p:nvPr/>
+        </p:nvSpPr>
+        <p:spPr>
+          <a:xfrm>
+            <a:off x="4480560" y="3657600"/>
+            <a:ext cx="2057400" cy="411480"/>
+          </a:xfrm>
+          <a:prstGeom prst="roundRect">
+            <a:avLst>
+              <a:gd name="adj" fmla="val 48889"/>
+            </a:avLst>
+          </a:prstGeom>
+          <a:solidFill>
+            <a:srgbClr val="F3ECD9"/>
+          </a:solidFill>
+          <a:ln w="12700">
+            <a:solidFill>
+              <a:srgbClr val="E2D5B4"/>
+            </a:solidFill>
+            <a:prstDash val="solid"/>
+          </a:ln>
+        </p:spPr>
+      </p:sp>
+      <p:sp>
+        <p:nvSpPr>
+          <p:cNvPr id="18" name="Text 16"/>
+          <p:cNvSpPr/>
+          <p:nvPr/>
+        </p:nvSpPr>
+        <p:spPr>
+          <a:xfrm>
+            <a:off x="4480560" y="3657600"/>
+            <a:ext cx="2057400" cy="411480"/>
+          </a:xfrm>
+          <a:prstGeom prst="rect">
+            <a:avLst/>
+          </a:prstGeom>
+          <a:noFill/>
+          <a:ln/>
+        </p:spPr>
+        <p:txBody>
+          <a:bodyPr wrap="square" lIns="0" tIns="0" rIns="0" bIns="0" rtlCol="0" anchor="ctr"/>
+          <a:lstStyle/>
+          <a:p>
+            <a:pPr algn="ctr" indent="0" marL="0">
+              <a:buNone/>
+            </a:pPr>
+            <a:r>
+              <a:rPr lang="en-US" sz="1150" b="1" spc="100" kern="0" dirty="0">
+                <a:solidFill>
+                  <a:srgbClr val="8A7440"/>
+                </a:solidFill>
+                <a:latin typeface="Arial" pitchFamily="34" charset="0"/>
+                <a:ea typeface="Arial" pitchFamily="34" charset="-122"/>
+                <a:cs typeface="Arial" pitchFamily="34" charset="-120"/>
+              </a:rPr>
+              <a:t>IN MONTHS</a:t>
+            </a:r>
+            <a:endParaRPr lang="en-US" sz="1150" dirty="0"/>
+          </a:p>
+        </p:txBody>
+      </p:sp>
+      <p:sp>
+        <p:nvSpPr>
+          <p:cNvPr id="19" name="Shape 17"/>
+          <p:cNvSpPr/>
+          <p:nvPr/>
+        </p:nvSpPr>
+        <p:spPr>
+          <a:xfrm>
+            <a:off x="6995160" y="3657600"/>
+            <a:ext cx="2057400" cy="411480"/>
+          </a:xfrm>
+          <a:prstGeom prst="roundRect">
+            <a:avLst>
+              <a:gd name="adj" fmla="val 48889"/>
+            </a:avLst>
+          </a:prstGeom>
+          <a:solidFill>
+            <a:srgbClr val="F3ECD9"/>
+          </a:solidFill>
+          <a:ln w="12700">
+            <a:solidFill>
+              <a:srgbClr val="E2D5B4"/>
+            </a:solidFill>
+            <a:prstDash val="solid"/>
+          </a:ln>
+        </p:spPr>
+      </p:sp>
+      <p:sp>
+        <p:nvSpPr>
+          <p:cNvPr id="20" name="Text 18"/>
+          <p:cNvSpPr/>
+          <p:nvPr/>
+        </p:nvSpPr>
+        <p:spPr>
+          <a:xfrm>
+            <a:off x="6995160" y="3657600"/>
+            <a:ext cx="2057400" cy="411480"/>
+          </a:xfrm>
+          <a:prstGeom prst="rect">
+            <a:avLst/>
+          </a:prstGeom>
+          <a:noFill/>
+          <a:ln/>
+        </p:spPr>
+        <p:txBody>
+          <a:bodyPr wrap="square" lIns="0" tIns="0" rIns="0" bIns="0" rtlCol="0" anchor="ctr"/>
+          <a:lstStyle/>
+          <a:p>
+            <a:pPr algn="ctr" indent="0" marL="0">
+              <a:buNone/>
+            </a:pPr>
+            <a:r>
+              <a:rPr lang="en-US" sz="1150" b="1" spc="100" kern="0" dirty="0">
+                <a:solidFill>
+                  <a:srgbClr val="8A7440"/>
+                </a:solidFill>
+                <a:latin typeface="Arial" pitchFamily="34" charset="0"/>
+                <a:ea typeface="Arial" pitchFamily="34" charset="-122"/>
+                <a:cs typeface="Arial" pitchFamily="34" charset="-120"/>
+              </a:rPr>
+              <a:t>STARTS AT 0</a:t>
+            </a:r>
+            <a:endParaRPr lang="en-US" sz="1150" dirty="0"/>
+          </a:p>
+        </p:txBody>
+      </p:sp>
+      <p:sp>
+        <p:nvSpPr>
+          <p:cNvPr id="21" name="Shape 19"/>
+          <p:cNvSpPr/>
+          <p:nvPr/>
+        </p:nvSpPr>
+        <p:spPr>
+          <a:xfrm>
+            <a:off x="9509760" y="3657600"/>
+            <a:ext cx="2057400" cy="411480"/>
+          </a:xfrm>
+          <a:prstGeom prst="roundRect">
+            <a:avLst>
+              <a:gd name="adj" fmla="val 48889"/>
+            </a:avLst>
+          </a:prstGeom>
+          <a:solidFill>
+            <a:srgbClr val="E4E9E7"/>
+          </a:solidFill>
+          <a:ln w="12700">
+            <a:solidFill>
+              <a:srgbClr val="D5DDDA"/>
+            </a:solidFill>
+            <a:prstDash val="solid"/>
+          </a:ln>
+        </p:spPr>
+      </p:sp>
+      <p:sp>
+        <p:nvSpPr>
+          <p:cNvPr id="22" name="Text 20"/>
+          <p:cNvSpPr/>
+          <p:nvPr/>
+        </p:nvSpPr>
+        <p:spPr>
+          <a:xfrm>
+            <a:off x="9509760" y="3657600"/>
+            <a:ext cx="2057400" cy="411480"/>
+          </a:xfrm>
+          <a:prstGeom prst="rect">
+            <a:avLst/>
+          </a:prstGeom>
+          <a:noFill/>
+          <a:ln/>
+        </p:spPr>
+        <p:txBody>
+          <a:bodyPr wrap="square" lIns="0" tIns="0" rIns="0" bIns="0" rtlCol="0" anchor="ctr"/>
+          <a:lstStyle/>
+          <a:p>
+            <a:pPr algn="ctr" indent="0" marL="0">
+              <a:buNone/>
+            </a:pPr>
+            <a:r>
+              <a:rPr lang="en-US" sz="1150" b="1" spc="100" kern="0" dirty="0">
+                <a:solidFill>
+                  <a:srgbClr val="5C6B70"/>
+                </a:solidFill>
+                <a:latin typeface="Arial" pitchFamily="34" charset="0"/>
+                <a:ea typeface="Arial" pitchFamily="34" charset="-122"/>
+                <a:cs typeface="Arial" pitchFamily="34" charset="-120"/>
+              </a:rPr>
+              <a:t>NO</a:t>
+            </a:r>
+            <a:endParaRPr lang="en-US" sz="1150" dirty="0"/>
+          </a:p>
+        </p:txBody>
+      </p:sp>
+      <p:sp>
+        <p:nvSpPr>
+          <p:cNvPr id="23" name="Text 21"/>
+          <p:cNvSpPr/>
+          <p:nvPr/>
+        </p:nvSpPr>
+        <p:spPr>
+          <a:xfrm>
+            <a:off x="594360" y="4389120"/>
+            <a:ext cx="3566160" cy="310896"/>
+          </a:xfrm>
+          <a:prstGeom prst="rect">
+            <a:avLst/>
+          </a:prstGeom>
+          <a:noFill/>
+          <a:ln/>
+        </p:spPr>
+        <p:txBody>
+          <a:bodyPr wrap="square" lIns="0" tIns="0" rIns="0" bIns="0" rtlCol="0" anchor="ctr"/>
           <a:lstStyle/>
           <a:p>
             <a:pPr indent="0" marL="0">
-              <a:lnSpc>
-                <a:spcPct val="114000"/>
-              </a:lnSpc>
-              <a:buNone/>
-            </a:pPr>
-            <a:r>
-              <a:rPr lang="en-US" sz="1200" dirty="0">
+              <a:buNone/>
+            </a:pPr>
+            <a:r>
+              <a:rPr lang="en-US" sz="1450" b="1" dirty="0">
                 <a:solidFill>
                   <a:srgbClr val="0E2726"/>
                 </a:solidFill>
@@ -9927,22 +10044,22 @@
                 <a:ea typeface="Arial" pitchFamily="34" charset="-122"/>
                 <a:cs typeface="Arial" pitchFamily="34" charset="-120"/>
               </a:rPr>
-              <a:t>A capable quant desk can rebuild a cone engine in months. What it cannot rebuild is a time-stamped public record with the misses kept — that can only be started, and ours started in June 2026. Building also moves the model risk onto your balance sheet instead of a supplier’s.</a:t>
-            </a:r>
-            <a:endParaRPr lang="en-US" sz="1200" dirty="0"/>
-          </a:p>
-        </p:txBody>
-      </p:sp>
-      <p:sp>
-        <p:nvSpPr>
-          <p:cNvPr id="8" name="Text 6"/>
-          <p:cNvSpPr/>
-          <p:nvPr/>
-        </p:nvSpPr>
-        <p:spPr>
-          <a:xfrm>
-            <a:off x="8147304" y="1783080"/>
-            <a:ext cx="3474720" cy="292608"/>
+              <a:t>Do nothing</a:t>
+            </a:r>
+            <a:endParaRPr lang="en-US" sz="1450" dirty="0"/>
+          </a:p>
+        </p:txBody>
+      </p:sp>
+      <p:sp>
+        <p:nvSpPr>
+          <p:cNvPr id="24" name="Text 22"/>
+          <p:cNvSpPr/>
+          <p:nvPr/>
+        </p:nvSpPr>
+        <p:spPr>
+          <a:xfrm>
+            <a:off x="594360" y="4718304"/>
+            <a:ext cx="3566160" cy="274320"/>
           </a:xfrm>
           <a:prstGeom prst="rect">
             <a:avLst/>
@@ -9958,49 +10075,547 @@
               <a:buNone/>
             </a:pPr>
             <a:r>
-              <a:rPr lang="en-US" sz="1300" b="1" spc="200" kern="0" dirty="0">
-                <a:solidFill>
-                  <a:srgbClr val="12796B"/>
-                </a:solidFill>
-                <a:latin typeface="Arial" pitchFamily="34" charset="0"/>
-                <a:ea typeface="Arial" pitchFamily="34" charset="-122"/>
-                <a:cs typeface="Arial" pitchFamily="34" charset="-120"/>
-              </a:rPr>
-              <a:t>DO NOTHING</a:t>
-            </a:r>
-            <a:endParaRPr lang="en-US" sz="1300" dirty="0"/>
-          </a:p>
-        </p:txBody>
-      </p:sp>
-      <p:sp>
-        <p:nvSpPr>
-          <p:cNvPr id="9" name="Text 7"/>
-          <p:cNvSpPr/>
-          <p:nvPr/>
-        </p:nvSpPr>
-        <p:spPr>
-          <a:xfrm>
-            <a:off x="8147304" y="2176272"/>
-            <a:ext cx="3520440" cy="3383280"/>
-          </a:xfrm>
-          <a:prstGeom prst="rect">
-            <a:avLst/>
-          </a:prstGeom>
-          <a:noFill/>
-          <a:ln/>
-        </p:spPr>
-        <p:txBody>
-          <a:bodyPr wrap="square" lIns="0" tIns="0" rIns="0" bIns="0" rtlCol="0" anchor="t"/>
+              <a:rPr lang="en-US" sz="950" i="1" dirty="0">
+                <a:solidFill>
+                  <a:srgbClr val="7A8A86"/>
+                </a:solidFill>
+                <a:latin typeface="Arial" pitchFamily="34" charset="0"/>
+                <a:ea typeface="Arial" pitchFamily="34" charset="-122"/>
+                <a:cs typeface="Arial" pitchFamily="34" charset="-120"/>
+              </a:rPr>
+              <a:t>the status quo for the long tail</a:t>
+            </a:r>
+            <a:endParaRPr lang="en-US" sz="950" dirty="0"/>
+          </a:p>
+        </p:txBody>
+      </p:sp>
+      <p:sp>
+        <p:nvSpPr>
+          <p:cNvPr id="25" name="Shape 23"/>
+          <p:cNvSpPr/>
+          <p:nvPr/>
+        </p:nvSpPr>
+        <p:spPr>
+          <a:xfrm>
+            <a:off x="4480560" y="4480560"/>
+            <a:ext cx="2057400" cy="411480"/>
+          </a:xfrm>
+          <a:prstGeom prst="roundRect">
+            <a:avLst>
+              <a:gd name="adj" fmla="val 48889"/>
+            </a:avLst>
+          </a:prstGeom>
+          <a:solidFill>
+            <a:srgbClr val="E4E9E7"/>
+          </a:solidFill>
+          <a:ln w="12700">
+            <a:solidFill>
+              <a:srgbClr val="D5DDDA"/>
+            </a:solidFill>
+            <a:prstDash val="solid"/>
+          </a:ln>
+        </p:spPr>
+      </p:sp>
+      <p:sp>
+        <p:nvSpPr>
+          <p:cNvPr id="26" name="Text 24"/>
+          <p:cNvSpPr/>
+          <p:nvPr/>
+        </p:nvSpPr>
+        <p:spPr>
+          <a:xfrm>
+            <a:off x="4480560" y="4480560"/>
+            <a:ext cx="2057400" cy="411480"/>
+          </a:xfrm>
+          <a:prstGeom prst="rect">
+            <a:avLst/>
+          </a:prstGeom>
+          <a:noFill/>
+          <a:ln/>
+        </p:spPr>
+        <p:txBody>
+          <a:bodyPr wrap="square" lIns="0" tIns="0" rIns="0" bIns="0" rtlCol="0" anchor="ctr"/>
+          <a:lstStyle/>
+          <a:p>
+            <a:pPr algn="ctr" indent="0" marL="0">
+              <a:buNone/>
+            </a:pPr>
+            <a:r>
+              <a:rPr lang="en-US" sz="1150" b="1" spc="100" kern="0" dirty="0">
+                <a:solidFill>
+                  <a:srgbClr val="5C6B70"/>
+                </a:solidFill>
+                <a:latin typeface="Arial" pitchFamily="34" charset="0"/>
+                <a:ea typeface="Arial" pitchFamily="34" charset="-122"/>
+                <a:cs typeface="Arial" pitchFamily="34" charset="-120"/>
+              </a:rPr>
+              <a:t>NO</a:t>
+            </a:r>
+            <a:endParaRPr lang="en-US" sz="1150" dirty="0"/>
+          </a:p>
+        </p:txBody>
+      </p:sp>
+      <p:sp>
+        <p:nvSpPr>
+          <p:cNvPr id="27" name="Shape 25"/>
+          <p:cNvSpPr/>
+          <p:nvPr/>
+        </p:nvSpPr>
+        <p:spPr>
+          <a:xfrm>
+            <a:off x="6995160" y="4480560"/>
+            <a:ext cx="2057400" cy="411480"/>
+          </a:xfrm>
+          <a:prstGeom prst="roundRect">
+            <a:avLst>
+              <a:gd name="adj" fmla="val 48889"/>
+            </a:avLst>
+          </a:prstGeom>
+          <a:solidFill>
+            <a:srgbClr val="E4E9E7"/>
+          </a:solidFill>
+          <a:ln w="12700">
+            <a:solidFill>
+              <a:srgbClr val="D5DDDA"/>
+            </a:solidFill>
+            <a:prstDash val="solid"/>
+          </a:ln>
+        </p:spPr>
+      </p:sp>
+      <p:sp>
+        <p:nvSpPr>
+          <p:cNvPr id="28" name="Text 26"/>
+          <p:cNvSpPr/>
+          <p:nvPr/>
+        </p:nvSpPr>
+        <p:spPr>
+          <a:xfrm>
+            <a:off x="6995160" y="4480560"/>
+            <a:ext cx="2057400" cy="411480"/>
+          </a:xfrm>
+          <a:prstGeom prst="rect">
+            <a:avLst/>
+          </a:prstGeom>
+          <a:noFill/>
+          <a:ln/>
+        </p:spPr>
+        <p:txBody>
+          <a:bodyPr wrap="square" lIns="0" tIns="0" rIns="0" bIns="0" rtlCol="0" anchor="ctr"/>
+          <a:lstStyle/>
+          <a:p>
+            <a:pPr algn="ctr" indent="0" marL="0">
+              <a:buNone/>
+            </a:pPr>
+            <a:r>
+              <a:rPr lang="en-US" sz="1150" b="1" spc="100" kern="0" dirty="0">
+                <a:solidFill>
+                  <a:srgbClr val="5C6B70"/>
+                </a:solidFill>
+                <a:latin typeface="Arial" pitchFamily="34" charset="0"/>
+                <a:ea typeface="Arial" pitchFamily="34" charset="-122"/>
+                <a:cs typeface="Arial" pitchFamily="34" charset="-120"/>
+              </a:rPr>
+              <a:t>NO</a:t>
+            </a:r>
+            <a:endParaRPr lang="en-US" sz="1150" dirty="0"/>
+          </a:p>
+        </p:txBody>
+      </p:sp>
+      <p:sp>
+        <p:nvSpPr>
+          <p:cNvPr id="29" name="Shape 27"/>
+          <p:cNvSpPr/>
+          <p:nvPr/>
+        </p:nvSpPr>
+        <p:spPr>
+          <a:xfrm>
+            <a:off x="9509760" y="4480560"/>
+            <a:ext cx="2057400" cy="411480"/>
+          </a:xfrm>
+          <a:prstGeom prst="roundRect">
+            <a:avLst>
+              <a:gd name="adj" fmla="val 48889"/>
+            </a:avLst>
+          </a:prstGeom>
+          <a:solidFill>
+            <a:srgbClr val="F3ECD9"/>
+          </a:solidFill>
+          <a:ln w="12700">
+            <a:solidFill>
+              <a:srgbClr val="E2D5B4"/>
+            </a:solidFill>
+            <a:prstDash val="solid"/>
+          </a:ln>
+        </p:spPr>
+      </p:sp>
+      <p:sp>
+        <p:nvSpPr>
+          <p:cNvPr id="30" name="Text 28"/>
+          <p:cNvSpPr/>
+          <p:nvPr/>
+        </p:nvSpPr>
+        <p:spPr>
+          <a:xfrm>
+            <a:off x="9509760" y="4480560"/>
+            <a:ext cx="2057400" cy="411480"/>
+          </a:xfrm>
+          <a:prstGeom prst="rect">
+            <a:avLst/>
+          </a:prstGeom>
+          <a:noFill/>
+          <a:ln/>
+        </p:spPr>
+        <p:txBody>
+          <a:bodyPr wrap="square" lIns="0" tIns="0" rIns="0" bIns="0" rtlCol="0" anchor="ctr"/>
+          <a:lstStyle/>
+          <a:p>
+            <a:pPr algn="ctr" indent="0" marL="0">
+              <a:buNone/>
+            </a:pPr>
+            <a:r>
+              <a:rPr lang="en-US" sz="1150" b="1" spc="100" kern="0" dirty="0">
+                <a:solidFill>
+                  <a:srgbClr val="8A7440"/>
+                </a:solidFill>
+                <a:latin typeface="Arial" pitchFamily="34" charset="0"/>
+                <a:ea typeface="Arial" pitchFamily="34" charset="-122"/>
+                <a:cs typeface="Arial" pitchFamily="34" charset="-120"/>
+              </a:rPr>
+              <a:t>TELEGRAM</a:t>
+            </a:r>
+            <a:endParaRPr lang="en-US" sz="1150" dirty="0"/>
+          </a:p>
+        </p:txBody>
+      </p:sp>
+      <p:sp>
+        <p:nvSpPr>
+          <p:cNvPr id="31" name="Shape 29"/>
+          <p:cNvSpPr/>
+          <p:nvPr/>
+        </p:nvSpPr>
+        <p:spPr>
+          <a:xfrm>
+            <a:off x="484632" y="5084064"/>
+            <a:ext cx="11338560" cy="841248"/>
+          </a:xfrm>
+          <a:prstGeom prst="roundRect">
+            <a:avLst>
+              <a:gd name="adj" fmla="val 7609"/>
+            </a:avLst>
+          </a:prstGeom>
+          <a:solidFill>
+            <a:srgbClr val="E7F0EE"/>
+          </a:solidFill>
+          <a:ln w="12700">
+            <a:solidFill>
+              <a:srgbClr val="CBDDD8"/>
+            </a:solidFill>
+            <a:prstDash val="solid"/>
+          </a:ln>
+        </p:spPr>
+      </p:sp>
+      <p:sp>
+        <p:nvSpPr>
+          <p:cNvPr id="32" name="Text 30"/>
+          <p:cNvSpPr/>
+          <p:nvPr/>
+        </p:nvSpPr>
+        <p:spPr>
+          <a:xfrm>
+            <a:off x="594360" y="5212080"/>
+            <a:ext cx="3566160" cy="310896"/>
+          </a:xfrm>
+          <a:prstGeom prst="rect">
+            <a:avLst/>
+          </a:prstGeom>
+          <a:noFill/>
+          <a:ln/>
+        </p:spPr>
+        <p:txBody>
+          <a:bodyPr wrap="square" lIns="0" tIns="0" rIns="0" bIns="0" rtlCol="0" anchor="ctr"/>
           <a:lstStyle/>
           <a:p>
             <a:pPr indent="0" marL="0">
-              <a:lnSpc>
-                <a:spcPct val="114000"/>
-              </a:lnSpc>
-              <a:buNone/>
-            </a:pPr>
-            <a:r>
-              <a:rPr lang="en-US" sz="1200" dirty="0">
+              <a:buNone/>
+            </a:pPr>
+            <a:r>
+              <a:rPr lang="en-US" sz="1450" b="1" dirty="0">
+                <a:solidFill>
+                  <a:srgbClr val="0F5147"/>
+                </a:solidFill>
+                <a:latin typeface="Arial" pitchFamily="34" charset="0"/>
+                <a:ea typeface="Arial" pitchFamily="34" charset="-122"/>
+                <a:cs typeface="Arial" pitchFamily="34" charset="-120"/>
+              </a:rPr>
+              <a:t>Testahil</a:t>
+            </a:r>
+            <a:endParaRPr lang="en-US" sz="1450" dirty="0"/>
+          </a:p>
+        </p:txBody>
+      </p:sp>
+      <p:sp>
+        <p:nvSpPr>
+          <p:cNvPr id="33" name="Text 31"/>
+          <p:cNvSpPr/>
+          <p:nvPr/>
+        </p:nvSpPr>
+        <p:spPr>
+          <a:xfrm>
+            <a:off x="594360" y="5541264"/>
+            <a:ext cx="3566160" cy="274320"/>
+          </a:xfrm>
+          <a:prstGeom prst="rect">
+            <a:avLst/>
+          </a:prstGeom>
+          <a:noFill/>
+          <a:ln/>
+        </p:spPr>
+        <p:txBody>
+          <a:bodyPr wrap="square" lIns="0" tIns="0" rIns="0" bIns="0" rtlCol="0" anchor="ctr"/>
+          <a:lstStyle/>
+          <a:p>
+            <a:pPr indent="0" marL="0">
+              <a:buNone/>
+            </a:pPr>
+            <a:r>
+              <a:rPr lang="en-US" sz="950" i="1" dirty="0">
+                <a:solidFill>
+                  <a:srgbClr val="7A8A86"/>
+                </a:solidFill>
+                <a:latin typeface="Arial" pitchFamily="34" charset="0"/>
+                <a:ea typeface="Arial" pitchFamily="34" charset="-122"/>
+                <a:cs typeface="Arial" pitchFamily="34" charset="-120"/>
+              </a:rPr>
+              <a:t>live at testahil.com</a:t>
+            </a:r>
+            <a:endParaRPr lang="en-US" sz="950" dirty="0"/>
+          </a:p>
+        </p:txBody>
+      </p:sp>
+      <p:sp>
+        <p:nvSpPr>
+          <p:cNvPr id="34" name="Shape 32"/>
+          <p:cNvSpPr/>
+          <p:nvPr/>
+        </p:nvSpPr>
+        <p:spPr>
+          <a:xfrm>
+            <a:off x="4480560" y="5303520"/>
+            <a:ext cx="2057400" cy="411480"/>
+          </a:xfrm>
+          <a:prstGeom prst="roundRect">
+            <a:avLst>
+              <a:gd name="adj" fmla="val 48889"/>
+            </a:avLst>
+          </a:prstGeom>
+          <a:solidFill>
+            <a:srgbClr val="12796B"/>
+          </a:solidFill>
+          <a:ln w="12700">
+            <a:solidFill>
+              <a:srgbClr val="12796B"/>
+            </a:solidFill>
+            <a:prstDash val="solid"/>
+          </a:ln>
+        </p:spPr>
+      </p:sp>
+      <p:sp>
+        <p:nvSpPr>
+          <p:cNvPr id="35" name="Text 33"/>
+          <p:cNvSpPr/>
+          <p:nvPr/>
+        </p:nvSpPr>
+        <p:spPr>
+          <a:xfrm>
+            <a:off x="4480560" y="5303520"/>
+            <a:ext cx="2057400" cy="411480"/>
+          </a:xfrm>
+          <a:prstGeom prst="rect">
+            <a:avLst/>
+          </a:prstGeom>
+          <a:noFill/>
+          <a:ln/>
+        </p:spPr>
+        <p:txBody>
+          <a:bodyPr wrap="square" lIns="0" tIns="0" rIns="0" bIns="0" rtlCol="0" anchor="ctr"/>
+          <a:lstStyle/>
+          <a:p>
+            <a:pPr algn="ctr" indent="0" marL="0">
+              <a:buNone/>
+            </a:pPr>
+            <a:r>
+              <a:rPr lang="en-US" sz="1150" b="1" spc="100" kern="0" dirty="0">
+                <a:solidFill>
+                  <a:srgbClr val="FFFFFF"/>
+                </a:solidFill>
+                <a:latin typeface="Arial" pitchFamily="34" charset="0"/>
+                <a:ea typeface="Arial" pitchFamily="34" charset="-122"/>
+                <a:cs typeface="Arial" pitchFamily="34" charset="-120"/>
+              </a:rPr>
+              <a:t>91 NAMES</a:t>
+            </a:r>
+            <a:endParaRPr lang="en-US" sz="1150" dirty="0"/>
+          </a:p>
+        </p:txBody>
+      </p:sp>
+      <p:sp>
+        <p:nvSpPr>
+          <p:cNvPr id="36" name="Shape 34"/>
+          <p:cNvSpPr/>
+          <p:nvPr/>
+        </p:nvSpPr>
+        <p:spPr>
+          <a:xfrm>
+            <a:off x="6995160" y="5303520"/>
+            <a:ext cx="2057400" cy="411480"/>
+          </a:xfrm>
+          <a:prstGeom prst="roundRect">
+            <a:avLst>
+              <a:gd name="adj" fmla="val 48889"/>
+            </a:avLst>
+          </a:prstGeom>
+          <a:solidFill>
+            <a:srgbClr val="12796B"/>
+          </a:solidFill>
+          <a:ln w="12700">
+            <a:solidFill>
+              <a:srgbClr val="12796B"/>
+            </a:solidFill>
+            <a:prstDash val="solid"/>
+          </a:ln>
+        </p:spPr>
+      </p:sp>
+      <p:sp>
+        <p:nvSpPr>
+          <p:cNvPr id="37" name="Text 35"/>
+          <p:cNvSpPr/>
+          <p:nvPr/>
+        </p:nvSpPr>
+        <p:spPr>
+          <a:xfrm>
+            <a:off x="6995160" y="5303520"/>
+            <a:ext cx="2057400" cy="411480"/>
+          </a:xfrm>
+          <a:prstGeom prst="rect">
+            <a:avLst/>
+          </a:prstGeom>
+          <a:noFill/>
+          <a:ln/>
+        </p:spPr>
+        <p:txBody>
+          <a:bodyPr wrap="square" lIns="0" tIns="0" rIns="0" bIns="0" rtlCol="0" anchor="ctr"/>
+          <a:lstStyle/>
+          <a:p>
+            <a:pPr algn="ctr" indent="0" marL="0">
+              <a:buNone/>
+            </a:pPr>
+            <a:r>
+              <a:rPr lang="en-US" sz="1150" b="1" spc="100" kern="0" dirty="0">
+                <a:solidFill>
+                  <a:srgbClr val="FFFFFF"/>
+                </a:solidFill>
+                <a:latin typeface="Arial" pitchFamily="34" charset="0"/>
+                <a:ea typeface="Arial" pitchFamily="34" charset="-122"/>
+                <a:cs typeface="Arial" pitchFamily="34" charset="-120"/>
+              </a:rPr>
+              <a:t>SINCE JUN-26</a:t>
+            </a:r>
+            <a:endParaRPr lang="en-US" sz="1150" dirty="0"/>
+          </a:p>
+        </p:txBody>
+      </p:sp>
+      <p:sp>
+        <p:nvSpPr>
+          <p:cNvPr id="38" name="Shape 36"/>
+          <p:cNvSpPr/>
+          <p:nvPr/>
+        </p:nvSpPr>
+        <p:spPr>
+          <a:xfrm>
+            <a:off x="9509760" y="5303520"/>
+            <a:ext cx="2057400" cy="411480"/>
+          </a:xfrm>
+          <a:prstGeom prst="roundRect">
+            <a:avLst>
+              <a:gd name="adj" fmla="val 48889"/>
+            </a:avLst>
+          </a:prstGeom>
+          <a:solidFill>
+            <a:srgbClr val="12796B"/>
+          </a:solidFill>
+          <a:ln w="12700">
+            <a:solidFill>
+              <a:srgbClr val="12796B"/>
+            </a:solidFill>
+            <a:prstDash val="solid"/>
+          </a:ln>
+        </p:spPr>
+      </p:sp>
+      <p:sp>
+        <p:nvSpPr>
+          <p:cNvPr id="39" name="Text 37"/>
+          <p:cNvSpPr/>
+          <p:nvPr/>
+        </p:nvSpPr>
+        <p:spPr>
+          <a:xfrm>
+            <a:off x="9509760" y="5303520"/>
+            <a:ext cx="2057400" cy="411480"/>
+          </a:xfrm>
+          <a:prstGeom prst="rect">
+            <a:avLst/>
+          </a:prstGeom>
+          <a:noFill/>
+          <a:ln/>
+        </p:spPr>
+        <p:txBody>
+          <a:bodyPr wrap="square" lIns="0" tIns="0" rIns="0" bIns="0" rtlCol="0" anchor="ctr"/>
+          <a:lstStyle/>
+          <a:p>
+            <a:pPr algn="ctr" indent="0" marL="0">
+              <a:buNone/>
+            </a:pPr>
+            <a:r>
+              <a:rPr lang="en-US" sz="1150" b="1" spc="100" kern="0" dirty="0">
+                <a:solidFill>
+                  <a:srgbClr val="FFFFFF"/>
+                </a:solidFill>
+                <a:latin typeface="Arial" pitchFamily="34" charset="0"/>
+                <a:ea typeface="Arial" pitchFamily="34" charset="-122"/>
+                <a:cs typeface="Arial" pitchFamily="34" charset="-120"/>
+              </a:rPr>
+              <a:t>YES</a:t>
+            </a:r>
+            <a:endParaRPr lang="en-US" sz="1150" dirty="0"/>
+          </a:p>
+        </p:txBody>
+      </p:sp>
+      <p:sp>
+        <p:nvSpPr>
+          <p:cNvPr id="40" name="Text 38"/>
+          <p:cNvSpPr/>
+          <p:nvPr/>
+        </p:nvSpPr>
+        <p:spPr>
+          <a:xfrm>
+            <a:off x="594360" y="6144768"/>
+            <a:ext cx="10972800" cy="411480"/>
+          </a:xfrm>
+          <a:prstGeom prst="rect">
+            <a:avLst/>
+          </a:prstGeom>
+          <a:noFill/>
+          <a:ln/>
+        </p:spPr>
+        <p:txBody>
+          <a:bodyPr wrap="square" lIns="0" tIns="0" rIns="0" bIns="0" rtlCol="0" anchor="ctr"/>
+          <a:lstStyle/>
+          <a:p>
+            <a:pPr indent="0" marL="0">
+              <a:buNone/>
+            </a:pPr>
+            <a:r>
+              <a:rPr lang="en-US" sz="1500" i="1" dirty="0">
                 <a:solidFill>
                   <a:srgbClr val="0E2726"/>
                 </a:solidFill>
@@ -10008,45 +10623,6 @@
                 <a:ea typeface="Arial" pitchFamily="34" charset="-122"/>
                 <a:cs typeface="Arial" pitchFamily="34" charset="-120"/>
               </a:rPr>
-              <a:t>The status quo for the long tail: clients trade those names on Telegram tips and social media. That is the real competitor for the coverage gap — and the one that produces the churn.</a:t>
-            </a:r>
-            <a:endParaRPr lang="en-US" sz="1200" dirty="0"/>
-          </a:p>
-        </p:txBody>
-      </p:sp>
-      <p:sp>
-        <p:nvSpPr>
-          <p:cNvPr id="10" name="Text 8"/>
-          <p:cNvSpPr/>
-          <p:nvPr/>
-        </p:nvSpPr>
-        <p:spPr>
-          <a:xfrm>
-            <a:off x="594360" y="5943600"/>
-            <a:ext cx="10972800" cy="411480"/>
-          </a:xfrm>
-          <a:prstGeom prst="rect">
-            <a:avLst/>
-          </a:prstGeom>
-          <a:noFill/>
-          <a:ln/>
-        </p:spPr>
-        <p:txBody>
-          <a:bodyPr wrap="square" lIns="0" tIns="0" rIns="0" bIns="0" rtlCol="0" anchor="ctr"/>
-          <a:lstStyle/>
-          <a:p>
-            <a:pPr indent="0" marL="0">
-              <a:buNone/>
-            </a:pPr>
-            <a:r>
-              <a:rPr lang="en-US" sz="1500" i="1" dirty="0">
-                <a:solidFill>
-                  <a:srgbClr val="0E2726"/>
-                </a:solidFill>
-                <a:latin typeface="Arial" pitchFamily="34" charset="0"/>
-                <a:ea typeface="Arial" pitchFamily="34" charset="-122"/>
-                <a:cs typeface="Arial" pitchFamily="34" charset="-120"/>
-              </a:rPr>
               <a:t>We are not asking you to replace a vendor. We are asking you to cover the names no vendor covers.</a:t>
             </a:r>
             <a:endParaRPr lang="en-US" sz="1500" dirty="0"/>
@@ -10055,7 +10631,7 @@
       </p:sp>
       <p:sp>
         <p:nvSpPr>
-          <p:cNvPr id="11" name="Text 9"/>
+          <p:cNvPr id="41" name="Text 39"/>
           <p:cNvSpPr/>
           <p:nvPr/>
         </p:nvSpPr>
@@ -14966,16 +15542,40 @@
           </a:p>
         </p:txBody>
       </p:sp>
-      <p:sp>
-        <p:nvSpPr>
-          <p:cNvPr id="4" name="Text 2"/>
-          <p:cNvSpPr/>
-          <p:nvPr/>
-        </p:nvSpPr>
-        <p:spPr>
-          <a:xfrm>
-            <a:off x="594360" y="1444752"/>
-            <a:ext cx="10515600" cy="365760"/>
+      <p:pic>
+        <p:nvPicPr>
+          <p:cNvPr id="4" name="Image 0" descr="asset_business.png">    </p:cNvPr>
+          <p:cNvPicPr>
+            <a:picLocks noChangeAspect="1"/>
+          </p:cNvPicPr>
+          <p:nvPr/>
+        </p:nvPicPr>
+        <p:blipFill>
+          <a:blip r:embed="rId1"/>
+          <a:stretch>
+            <a:fillRect/>
+          </a:stretch>
+        </p:blipFill>
+        <p:spPr>
+          <a:xfrm>
+            <a:off x="594360" y="1481328"/>
+            <a:ext cx="11000232" cy="4032504"/>
+          </a:xfrm>
+          <a:prstGeom prst="rect">
+            <a:avLst/>
+          </a:prstGeom>
+        </p:spPr>
+      </p:pic>
+      <p:sp>
+        <p:nvSpPr>
+          <p:cNvPr id="5" name="Text 2"/>
+          <p:cNvSpPr/>
+          <p:nvPr/>
+        </p:nvSpPr>
+        <p:spPr>
+          <a:xfrm>
+            <a:off x="594360" y="5596128"/>
+            <a:ext cx="5257800" cy="502920"/>
           </a:xfrm>
           <a:prstGeom prst="rect">
             <a:avLst/>
@@ -14991,7 +15591,7 @@
               <a:buNone/>
             </a:pPr>
             <a:r>
-              <a:rPr lang="en-US" sz="1500" dirty="0">
+              <a:rPr lang="en-US" sz="1200" dirty="0">
                 <a:solidFill>
                   <a:srgbClr val="5C6B70"/>
                 </a:solidFill>
@@ -14999,49 +15599,61 @@
                 <a:ea typeface="Arial" pitchFamily="34" charset="-122"/>
                 <a:cs typeface="Arial" pitchFamily="34" charset="-120"/>
               </a:rPr>
-              <a:t>Accessible, honest research doesn’t just serve the market — it grows it.</a:t>
-            </a:r>
-            <a:endParaRPr lang="en-US" sz="1500" dirty="0"/>
-          </a:p>
-        </p:txBody>
-      </p:sp>
-      <p:sp>
-        <p:nvSpPr>
-          <p:cNvPr id="5" name="Shape 3"/>
-          <p:cNvSpPr/>
-          <p:nvPr/>
-        </p:nvSpPr>
-        <p:spPr>
-          <a:xfrm>
-            <a:off x="594360" y="2011680"/>
-            <a:ext cx="5349240" cy="3291840"/>
-          </a:xfrm>
-          <a:prstGeom prst="roundRect">
-            <a:avLst>
-              <a:gd name="adj" fmla="val 2222"/>
-            </a:avLst>
-          </a:prstGeom>
-          <a:solidFill>
-            <a:srgbClr val="FFFFFF"/>
-          </a:solidFill>
-          <a:ln w="12700">
-            <a:solidFill>
-              <a:srgbClr val="D9E4E1"/>
-            </a:solidFill>
-            <a:prstDash val="solid"/>
-          </a:ln>
-        </p:spPr>
-      </p:sp>
-      <p:sp>
-        <p:nvSpPr>
-          <p:cNvPr id="6" name="Text 4"/>
-          <p:cNvSpPr/>
-          <p:nvPr/>
-        </p:nvSpPr>
-        <p:spPr>
-          <a:xfrm>
-            <a:off x="868680" y="2267712"/>
-            <a:ext cx="4846320" cy="320040"/>
+              <a:t>Accessible odds create investors — and guided clients stay, trade, and fund the next name.</a:t>
+            </a:r>
+            <a:endParaRPr lang="en-US" sz="1200" dirty="0"/>
+          </a:p>
+        </p:txBody>
+      </p:sp>
+      <p:sp>
+        <p:nvSpPr>
+          <p:cNvPr id="6" name="Text 3"/>
+          <p:cNvSpPr/>
+          <p:nvPr/>
+        </p:nvSpPr>
+        <p:spPr>
+          <a:xfrm>
+            <a:off x="6263640" y="5596128"/>
+            <a:ext cx="5303520" cy="502920"/>
+          </a:xfrm>
+          <a:prstGeom prst="rect">
+            <a:avLst/>
+          </a:prstGeom>
+          <a:noFill/>
+          <a:ln/>
+        </p:spPr>
+        <p:txBody>
+          <a:bodyPr wrap="square" lIns="0" tIns="0" rIns="0" bIns="0" rtlCol="0" anchor="t"/>
+          <a:lstStyle/>
+          <a:p>
+            <a:pPr indent="0" marL="0">
+              <a:buNone/>
+            </a:pPr>
+            <a:r>
+              <a:rPr lang="en-US" sz="1200" dirty="0">
+                <a:solidFill>
+                  <a:srgbClr val="5C6B70"/>
+                </a:solidFill>
+                <a:latin typeface="Arial" pitchFamily="34" charset="0"/>
+                <a:ea typeface="Arial" pitchFamily="34" charset="-122"/>
+                <a:cs typeface="Arial" pitchFamily="34" charset="-120"/>
+              </a:rPr>
+              <a:t>One partner, one deep integration — scoped per country, per language, per feature tier.</a:t>
+            </a:r>
+            <a:endParaRPr lang="en-US" sz="1200" dirty="0"/>
+          </a:p>
+        </p:txBody>
+      </p:sp>
+      <p:sp>
+        <p:nvSpPr>
+          <p:cNvPr id="7" name="Text 4"/>
+          <p:cNvSpPr/>
+          <p:nvPr/>
+        </p:nvSpPr>
+        <p:spPr>
+          <a:xfrm>
+            <a:off x="594360" y="6172200"/>
+            <a:ext cx="10972800" cy="411480"/>
           </a:xfrm>
           <a:prstGeom prst="rect">
             <a:avLst/>
@@ -15057,52 +15669,7 @@
               <a:buNone/>
             </a:pPr>
             <a:r>
-              <a:rPr lang="en-US" sz="1400" b="1" spc="150" kern="0" dirty="0">
-                <a:solidFill>
-                  <a:srgbClr val="12796B"/>
-                </a:solidFill>
-                <a:latin typeface="Arial" pitchFamily="34" charset="0"/>
-                <a:ea typeface="Arial" pitchFamily="34" charset="-122"/>
-                <a:cs typeface="Arial" pitchFamily="34" charset="-120"/>
-              </a:rPr>
-              <a:t>GROW THE MARKET</a:t>
-            </a:r>
-            <a:endParaRPr lang="en-US" sz="1400" dirty="0"/>
-          </a:p>
-        </p:txBody>
-      </p:sp>
-      <p:sp>
-        <p:nvSpPr>
-          <p:cNvPr id="7" name="Text 5"/>
-          <p:cNvSpPr/>
-          <p:nvPr/>
-        </p:nvSpPr>
-        <p:spPr>
-          <a:xfrm>
-            <a:off x="868680" y="2697480"/>
-            <a:ext cx="4800600" cy="2468880"/>
-          </a:xfrm>
-          <a:prstGeom prst="rect">
-            <a:avLst/>
-          </a:prstGeom>
-          <a:noFill/>
-          <a:ln/>
-        </p:spPr>
-        <p:txBody>
-          <a:bodyPr wrap="square" lIns="0" tIns="0" rIns="0" bIns="0" rtlCol="0" anchor="t"/>
-          <a:lstStyle/>
-          <a:p>
-            <a:pPr indent="0" marL="0">
-              <a:lnSpc>
-                <a:spcPct val="108000"/>
-              </a:lnSpc>
-              <a:spcAft>
-                <a:spcPts val="1000"/>
-              </a:spcAft>
-              <a:buNone/>
-            </a:pPr>
-            <a:r>
-              <a:rPr lang="en-US" sz="1250" dirty="0">
+              <a:rPr lang="en-US" sz="1450" i="1" dirty="0">
                 <a:solidFill>
                   <a:srgbClr val="0E2726"/>
                 </a:solidFill>
@@ -15110,211 +15677,15 @@
                 <a:ea typeface="Arial" pitchFamily="34" charset="-122"/>
                 <a:cs typeface="Arial" pitchFamily="34" charset="-120"/>
               </a:rPr>
-              <a:t>Capture the new-investor wave — and create it. People who never invested because they couldn’t read the research finally get information they can act on.</a:t>
-            </a:r>
-            <a:endParaRPr lang="en-US" sz="1250" dirty="0"/>
-          </a:p>
-          <a:p>
-            <a:pPr indent="0" marL="0">
-              <a:lnSpc>
-                <a:spcPct val="108000"/>
-              </a:lnSpc>
-              <a:spcAft>
-                <a:spcPts val="1000"/>
-              </a:spcAft>
-              <a:buNone/>
-            </a:pPr>
-            <a:r>
-              <a:rPr lang="en-US" sz="1250" dirty="0">
-                <a:solidFill>
-                  <a:srgbClr val="0E2726"/>
-                </a:solidFill>
-                <a:latin typeface="Arial" pitchFamily="34" charset="0"/>
-                <a:ea typeface="Arial" pitchFamily="34" charset="-122"/>
-                <a:cs typeface="Arial" pitchFamily="34" charset="-120"/>
-              </a:rPr>
-              <a:t>Informed, accessible odds bring first-timers into Middle East and EM exchanges — and keep them. Guided clients engage more, stay longer, trade more.</a:t>
-            </a:r>
-            <a:endParaRPr lang="en-US" sz="1250" dirty="0"/>
-          </a:p>
-        </p:txBody>
-      </p:sp>
-      <p:sp>
-        <p:nvSpPr>
-          <p:cNvPr id="8" name="Shape 6"/>
-          <p:cNvSpPr/>
-          <p:nvPr/>
-        </p:nvSpPr>
-        <p:spPr>
-          <a:xfrm>
-            <a:off x="6263640" y="2011680"/>
-            <a:ext cx="5349240" cy="3291840"/>
-          </a:xfrm>
-          <a:prstGeom prst="roundRect">
-            <a:avLst>
-              <a:gd name="adj" fmla="val 2222"/>
-            </a:avLst>
-          </a:prstGeom>
-          <a:solidFill>
-            <a:srgbClr val="FFFFFF"/>
-          </a:solidFill>
-          <a:ln w="12700">
-            <a:solidFill>
-              <a:srgbClr val="D9E4E1"/>
-            </a:solidFill>
-            <a:prstDash val="solid"/>
-          </a:ln>
-        </p:spPr>
-      </p:sp>
-      <p:sp>
-        <p:nvSpPr>
-          <p:cNvPr id="9" name="Text 7"/>
-          <p:cNvSpPr/>
-          <p:nvPr/>
-        </p:nvSpPr>
-        <p:spPr>
-          <a:xfrm>
-            <a:off x="6537960" y="2267712"/>
-            <a:ext cx="4846320" cy="320040"/>
-          </a:xfrm>
-          <a:prstGeom prst="rect">
-            <a:avLst/>
-          </a:prstGeom>
-          <a:noFill/>
-          <a:ln/>
-        </p:spPr>
-        <p:txBody>
-          <a:bodyPr wrap="square" lIns="0" tIns="0" rIns="0" bIns="0" rtlCol="0" anchor="ctr"/>
-          <a:lstStyle/>
-          <a:p>
-            <a:pPr indent="0" marL="0">
-              <a:buNone/>
-            </a:pPr>
-            <a:r>
-              <a:rPr lang="en-US" sz="1400" b="1" spc="150" kern="0" dirty="0">
-                <a:solidFill>
-                  <a:srgbClr val="12796B"/>
-                </a:solidFill>
-                <a:latin typeface="Arial" pitchFamily="34" charset="0"/>
-                <a:ea typeface="Arial" pitchFamily="34" charset="-122"/>
-                <a:cs typeface="Arial" pitchFamily="34" charset="-120"/>
-              </a:rPr>
-              <a:t>ONE PARTNER, ONE INTEGRATION</a:t>
-            </a:r>
-            <a:endParaRPr lang="en-US" sz="1400" dirty="0"/>
-          </a:p>
-        </p:txBody>
-      </p:sp>
-      <p:sp>
-        <p:nvSpPr>
-          <p:cNvPr id="10" name="Text 8"/>
-          <p:cNvSpPr/>
-          <p:nvPr/>
-        </p:nvSpPr>
-        <p:spPr>
-          <a:xfrm>
-            <a:off x="6537960" y="2697480"/>
-            <a:ext cx="4800600" cy="2468880"/>
-          </a:xfrm>
-          <a:prstGeom prst="rect">
-            <a:avLst/>
-          </a:prstGeom>
-          <a:noFill/>
-          <a:ln/>
-        </p:spPr>
-        <p:txBody>
-          <a:bodyPr wrap="square" lIns="0" tIns="0" rIns="0" bIns="0" rtlCol="0" anchor="t"/>
-          <a:lstStyle/>
-          <a:p>
-            <a:pPr indent="0" marL="0">
-              <a:lnSpc>
-                <a:spcPct val="108000"/>
-              </a:lnSpc>
-              <a:spcAft>
-                <a:spcPts val="1000"/>
-              </a:spcAft>
-              <a:buNone/>
-            </a:pPr>
-            <a:r>
-              <a:rPr lang="en-US" sz="1250" dirty="0">
-                <a:solidFill>
-                  <a:srgbClr val="0E2726"/>
-                </a:solidFill>
-                <a:latin typeface="Arial" pitchFamily="34" charset="0"/>
-                <a:ea typeface="Arial" pitchFamily="34" charset="-122"/>
-                <a:cs typeface="Arial" pitchFamily="34" charset="-120"/>
-              </a:rPr>
-              <a:t>One deep integration — scoped per country, per language, per feature tier — delivered white-label or by API under your umbrella.</a:t>
-            </a:r>
-            <a:endParaRPr lang="en-US" sz="1250" dirty="0"/>
-          </a:p>
-          <a:p>
-            <a:pPr indent="0" marL="0">
-              <a:lnSpc>
-                <a:spcPct val="108000"/>
-              </a:lnSpc>
-              <a:spcAft>
-                <a:spcPts val="1000"/>
-              </a:spcAft>
-              <a:buNone/>
-            </a:pPr>
-            <a:r>
-              <a:rPr lang="en-US" sz="1250" dirty="0">
-                <a:solidFill>
-                  <a:srgbClr val="0E2726"/>
-                </a:solidFill>
-                <a:latin typeface="Arial" pitchFamily="34" charset="0"/>
-                <a:ea typeface="Arial" pitchFamily="34" charset="-122"/>
-                <a:cs typeface="Arial" pitchFamily="34" charset="-120"/>
-              </a:rPr>
-              <a:t>Premium modules by tier: Ticker Picker, Compare, Trade and Portfolio roll out as licensed features, not giveaways. Your return: engagement, retention, volume — and first-mover ownership of publicly-graded AI research in your markets.</a:t>
-            </a:r>
-            <a:endParaRPr lang="en-US" sz="1250" dirty="0"/>
-          </a:p>
-        </p:txBody>
-      </p:sp>
-      <p:sp>
-        <p:nvSpPr>
-          <p:cNvPr id="11" name="Text 9"/>
-          <p:cNvSpPr/>
-          <p:nvPr/>
-        </p:nvSpPr>
-        <p:spPr>
-          <a:xfrm>
-            <a:off x="594360" y="5806440"/>
-            <a:ext cx="10972800" cy="548640"/>
-          </a:xfrm>
-          <a:prstGeom prst="rect">
-            <a:avLst/>
-          </a:prstGeom>
-          <a:noFill/>
-          <a:ln/>
-        </p:spPr>
-        <p:txBody>
-          <a:bodyPr wrap="square" lIns="0" tIns="0" rIns="0" bIns="0" rtlCol="0" anchor="t"/>
-          <a:lstStyle/>
-          <a:p>
-            <a:pPr indent="0" marL="0">
-              <a:buNone/>
-            </a:pPr>
-            <a:r>
-              <a:rPr lang="en-US" sz="1400" i="1" dirty="0">
-                <a:solidFill>
-                  <a:srgbClr val="0E2726"/>
-                </a:solidFill>
-                <a:latin typeface="Arial" pitchFamily="34" charset="0"/>
-                <a:ea typeface="Arial" pitchFamily="34" charset="-122"/>
-                <a:cs typeface="Arial" pitchFamily="34" charset="-120"/>
-              </a:rPr>
-              <a:t>One engine: the marginal name is nearly free. Each new market carries its own data, licensing and residency cost — priced openly, never buried.</a:t>
-            </a:r>
-            <a:endParaRPr lang="en-US" sz="1400" dirty="0"/>
-          </a:p>
-        </p:txBody>
-      </p:sp>
-      <p:sp>
-        <p:nvSpPr>
-          <p:cNvPr id="12" name="Text 10"/>
+              <a:t>The marginal name is nearly free. Each new market is priced openly — data, licensing, residency — never buried.</a:t>
+            </a:r>
+            <a:endParaRPr lang="en-US" sz="1450" dirty="0"/>
+          </a:p>
+        </p:txBody>
+      </p:sp>
+      <p:sp>
+        <p:nvSpPr>
+          <p:cNvPr id="8" name="Text 5"/>
           <p:cNvSpPr/>
           <p:nvPr/>
         </p:nvSpPr>
@@ -15455,49 +15826,46 @@
                 <a:ea typeface="Arial" pitchFamily="34" charset="-122"/>
                 <a:cs typeface="Arial" pitchFamily="34" charset="-120"/>
               </a:rPr>
-              <a:t>The ask: pilot → integrate → expand.</a:t>
+              <a:t>90 days to an answer.</a:t>
             </a:r>
             <a:endParaRPr lang="en-US" sz="3400" dirty="0"/>
           </a:p>
         </p:txBody>
       </p:sp>
-      <p:sp>
-        <p:nvSpPr>
-          <p:cNvPr id="4" name="Shape 2"/>
-          <p:cNvSpPr/>
-          <p:nvPr/>
-        </p:nvSpPr>
-        <p:spPr>
-          <a:xfrm>
-            <a:off x="594360" y="1645920"/>
-            <a:ext cx="3566160" cy="3246120"/>
-          </a:xfrm>
-          <a:prstGeom prst="roundRect">
-            <a:avLst>
-              <a:gd name="adj" fmla="val 2254"/>
-            </a:avLst>
-          </a:prstGeom>
-          <a:solidFill>
-            <a:srgbClr val="FFFFFF"/>
-          </a:solidFill>
-          <a:ln w="12700">
-            <a:solidFill>
-              <a:srgbClr val="D9E4E1"/>
-            </a:solidFill>
-            <a:prstDash val="solid"/>
-          </a:ln>
-        </p:spPr>
-      </p:sp>
-      <p:sp>
-        <p:nvSpPr>
-          <p:cNvPr id="5" name="Text 3"/>
-          <p:cNvSpPr/>
-          <p:nvPr/>
-        </p:nvSpPr>
-        <p:spPr>
-          <a:xfrm>
-            <a:off x="832104" y="1874520"/>
-            <a:ext cx="3108960" cy="320040"/>
+      <p:pic>
+        <p:nvPicPr>
+          <p:cNvPr id="4" name="Image 0" descr="asset_timeline.png">    </p:cNvPr>
+          <p:cNvPicPr>
+            <a:picLocks noChangeAspect="1"/>
+          </p:cNvPicPr>
+          <p:nvPr/>
+        </p:nvPicPr>
+        <p:blipFill>
+          <a:blip r:embed="rId1"/>
+          <a:stretch>
+            <a:fillRect/>
+          </a:stretch>
+        </p:blipFill>
+        <p:spPr>
+          <a:xfrm>
+            <a:off x="594360" y="1536192"/>
+            <a:ext cx="11000232" cy="4123944"/>
+          </a:xfrm>
+          <a:prstGeom prst="rect">
+            <a:avLst/>
+          </a:prstGeom>
+        </p:spPr>
+      </p:pic>
+      <p:sp>
+        <p:nvSpPr>
+          <p:cNvPr id="5" name="Text 2"/>
+          <p:cNvSpPr/>
+          <p:nvPr/>
+        </p:nvSpPr>
+        <p:spPr>
+          <a:xfrm>
+            <a:off x="594360" y="5943600"/>
+            <a:ext cx="10972800" cy="411480"/>
           </a:xfrm>
           <a:prstGeom prst="rect">
             <a:avLst/>
@@ -15513,49 +15881,7 @@
               <a:buNone/>
             </a:pPr>
             <a:r>
-              <a:rPr lang="en-US" sz="1300" b="1" spc="150" kern="0" dirty="0">
-                <a:solidFill>
-                  <a:srgbClr val="12796B"/>
-                </a:solidFill>
-                <a:latin typeface="Arial" pitchFamily="34" charset="0"/>
-                <a:ea typeface="Arial" pitchFamily="34" charset="-122"/>
-                <a:cs typeface="Arial" pitchFamily="34" charset="-120"/>
-              </a:rPr>
-              <a:t>1 · THE PILOT</a:t>
-            </a:r>
-            <a:endParaRPr lang="en-US" sz="1300" dirty="0"/>
-          </a:p>
-        </p:txBody>
-      </p:sp>
-      <p:sp>
-        <p:nvSpPr>
-          <p:cNvPr id="6" name="Text 4"/>
-          <p:cNvSpPr/>
-          <p:nvPr/>
-        </p:nvSpPr>
-        <p:spPr>
-          <a:xfrm>
-            <a:off x="832104" y="2286000"/>
-            <a:ext cx="3108960" cy="2514600"/>
-          </a:xfrm>
-          <a:prstGeom prst="rect">
-            <a:avLst/>
-          </a:prstGeom>
-          <a:noFill/>
-          <a:ln/>
-        </p:spPr>
-        <p:txBody>
-          <a:bodyPr wrap="square" lIns="0" tIns="0" rIns="0" bIns="0" rtlCol="0" anchor="t"/>
-          <a:lstStyle/>
-          <a:p>
-            <a:pPr indent="0" marL="0">
-              <a:lnSpc>
-                <a:spcPct val="112000"/>
-              </a:lnSpc>
-              <a:buNone/>
-            </a:pPr>
-            <a:r>
-              <a:rPr lang="en-US" sz="1150" dirty="0">
+              <a:rPr lang="en-US" sz="1500" i="1" dirty="0">
                 <a:solidFill>
                   <a:srgbClr val="0E2726"/>
                 </a:solidFill>
@@ -15563,350 +15889,15 @@
                 <a:ea typeface="Arial" pitchFamily="34" charset="-122"/>
                 <a:cs typeface="Arial" pitchFamily="34" charset="-120"/>
               </a:rPr>
-              <a:t>A 90-day audited pilot on the 25 names your clients hold most — opening with the data room: the full 15-year calibration archive, every window, every cone, every miss, plus a verification script your quants run to reproduce the 90.6% before any client sees a number.</a:t>
-            </a:r>
-            <a:endParaRPr lang="en-US" sz="1150" dirty="0"/>
-          </a:p>
-        </p:txBody>
-      </p:sp>
-      <p:sp>
-        <p:nvSpPr>
-          <p:cNvPr id="7" name="Shape 5"/>
-          <p:cNvSpPr/>
-          <p:nvPr/>
-        </p:nvSpPr>
-        <p:spPr>
-          <a:xfrm>
-            <a:off x="4370832" y="1645920"/>
-            <a:ext cx="3566160" cy="3246120"/>
-          </a:xfrm>
-          <a:prstGeom prst="roundRect">
-            <a:avLst>
-              <a:gd name="adj" fmla="val 2254"/>
-            </a:avLst>
-          </a:prstGeom>
-          <a:solidFill>
-            <a:srgbClr val="FFFFFF"/>
-          </a:solidFill>
-          <a:ln w="12700">
-            <a:solidFill>
-              <a:srgbClr val="D9E4E1"/>
-            </a:solidFill>
-            <a:prstDash val="solid"/>
-          </a:ln>
-        </p:spPr>
-      </p:sp>
-      <p:sp>
-        <p:nvSpPr>
-          <p:cNvPr id="8" name="Text 6"/>
-          <p:cNvSpPr/>
-          <p:nvPr/>
-        </p:nvSpPr>
-        <p:spPr>
-          <a:xfrm>
-            <a:off x="4608576" y="1874520"/>
-            <a:ext cx="3108960" cy="320040"/>
-          </a:xfrm>
-          <a:prstGeom prst="rect">
-            <a:avLst/>
-          </a:prstGeom>
-          <a:noFill/>
-          <a:ln/>
-        </p:spPr>
-        <p:txBody>
-          <a:bodyPr wrap="square" lIns="0" tIns="0" rIns="0" bIns="0" rtlCol="0" anchor="ctr"/>
-          <a:lstStyle/>
-          <a:p>
-            <a:pPr indent="0" marL="0">
-              <a:buNone/>
-            </a:pPr>
-            <a:r>
-              <a:rPr lang="en-US" sz="1300" b="1" spc="150" kern="0" dirty="0">
-                <a:solidFill>
-                  <a:srgbClr val="12796B"/>
-                </a:solidFill>
-                <a:latin typeface="Arial" pitchFamily="34" charset="0"/>
-                <a:ea typeface="Arial" pitchFamily="34" charset="-122"/>
-                <a:cs typeface="Arial" pitchFamily="34" charset="-120"/>
-              </a:rPr>
-              <a:t>2 · THE INTEGRATION</a:t>
-            </a:r>
-            <a:endParaRPr lang="en-US" sz="1300" dirty="0"/>
-          </a:p>
-        </p:txBody>
-      </p:sp>
-      <p:sp>
-        <p:nvSpPr>
-          <p:cNvPr id="9" name="Text 7"/>
-          <p:cNvSpPr/>
-          <p:nvPr/>
-        </p:nvSpPr>
-        <p:spPr>
-          <a:xfrm>
-            <a:off x="4608576" y="2286000"/>
-            <a:ext cx="3108960" cy="2514600"/>
-          </a:xfrm>
-          <a:prstGeom prst="rect">
-            <a:avLst/>
-          </a:prstGeom>
-          <a:noFill/>
-          <a:ln/>
-        </p:spPr>
-        <p:txBody>
-          <a:bodyPr wrap="square" lIns="0" tIns="0" rIns="0" bIns="0" rtlCol="0" anchor="t"/>
-          <a:lstStyle/>
-          <a:p>
-            <a:pPr indent="0" marL="0">
-              <a:lnSpc>
-                <a:spcPct val="112000"/>
-              </a:lnSpc>
-              <a:buNone/>
-            </a:pPr>
-            <a:r>
-              <a:rPr lang="en-US" sz="1150" dirty="0">
-                <a:solidFill>
-                  <a:srgbClr val="0E2726"/>
-                </a:solidFill>
-                <a:latin typeface="Arial" pitchFamily="34" charset="0"/>
-                <a:ea typeface="Arial" pitchFamily="34" charset="-122"/>
-                <a:cs typeface="Arial" pitchFamily="34" charset="-120"/>
-              </a:rPr>
-              <a:t>Testahil operates under your umbrella — white-label pages or API inside your app. Your analysts become the review layer on every published number, so the output is your firm’s process, not a third party’s black box.</a:t>
-            </a:r>
-            <a:endParaRPr lang="en-US" sz="1150" dirty="0"/>
-          </a:p>
-        </p:txBody>
-      </p:sp>
-      <p:sp>
-        <p:nvSpPr>
-          <p:cNvPr id="10" name="Shape 8"/>
-          <p:cNvSpPr/>
-          <p:nvPr/>
-        </p:nvSpPr>
-        <p:spPr>
-          <a:xfrm>
-            <a:off x="8147304" y="1645920"/>
-            <a:ext cx="3566160" cy="3246120"/>
-          </a:xfrm>
-          <a:prstGeom prst="roundRect">
-            <a:avLst>
-              <a:gd name="adj" fmla="val 2254"/>
-            </a:avLst>
-          </a:prstGeom>
-          <a:solidFill>
-            <a:srgbClr val="FFFFFF"/>
-          </a:solidFill>
-          <a:ln w="12700">
-            <a:solidFill>
-              <a:srgbClr val="D9E4E1"/>
-            </a:solidFill>
-            <a:prstDash val="solid"/>
-          </a:ln>
-        </p:spPr>
-      </p:sp>
-      <p:sp>
-        <p:nvSpPr>
-          <p:cNvPr id="11" name="Text 9"/>
-          <p:cNvSpPr/>
-          <p:nvPr/>
-        </p:nvSpPr>
-        <p:spPr>
-          <a:xfrm>
-            <a:off x="8385048" y="1874520"/>
-            <a:ext cx="3108960" cy="320040"/>
-          </a:xfrm>
-          <a:prstGeom prst="rect">
-            <a:avLst/>
-          </a:prstGeom>
-          <a:noFill/>
-          <a:ln/>
-        </p:spPr>
-        <p:txBody>
-          <a:bodyPr wrap="square" lIns="0" tIns="0" rIns="0" bIns="0" rtlCol="0" anchor="ctr"/>
-          <a:lstStyle/>
-          <a:p>
-            <a:pPr indent="0" marL="0">
-              <a:buNone/>
-            </a:pPr>
-            <a:r>
-              <a:rPr lang="en-US" sz="1300" b="1" spc="150" kern="0" dirty="0">
-                <a:solidFill>
-                  <a:srgbClr val="12796B"/>
-                </a:solidFill>
-                <a:latin typeface="Arial" pitchFamily="34" charset="0"/>
-                <a:ea typeface="Arial" pitchFamily="34" charset="-122"/>
-                <a:cs typeface="Arial" pitchFamily="34" charset="-120"/>
-              </a:rPr>
-              <a:t>3 · THE EXPANSION</a:t>
-            </a:r>
-            <a:endParaRPr lang="en-US" sz="1300" dirty="0"/>
-          </a:p>
-        </p:txBody>
-      </p:sp>
-      <p:sp>
-        <p:nvSpPr>
-          <p:cNvPr id="12" name="Text 10"/>
-          <p:cNvSpPr/>
-          <p:nvPr/>
-        </p:nvSpPr>
-        <p:spPr>
-          <a:xfrm>
-            <a:off x="8385048" y="2286000"/>
-            <a:ext cx="3108960" cy="2514600"/>
-          </a:xfrm>
-          <a:prstGeom prst="rect">
-            <a:avLst/>
-          </a:prstGeom>
-          <a:noFill/>
-          <a:ln/>
-        </p:spPr>
-        <p:txBody>
-          <a:bodyPr wrap="square" lIns="0" tIns="0" rIns="0" bIns="0" rtlCol="0" anchor="t"/>
-          <a:lstStyle/>
-          <a:p>
-            <a:pPr indent="0" marL="0">
-              <a:lnSpc>
-                <a:spcPct val="112000"/>
-              </a:lnSpc>
-              <a:buNone/>
-            </a:pPr>
-            <a:r>
-              <a:rPr lang="en-US" sz="1150" dirty="0">
-                <a:solidFill>
-                  <a:srgbClr val="0E2726"/>
-                </a:solidFill>
-                <a:latin typeface="Arial" pitchFamily="34" charset="0"/>
-                <a:ea typeface="Arial" pitchFamily="34" charset="-122"/>
-                <a:cs typeface="Arial" pitchFamily="34" charset="-120"/>
-              </a:rPr>
-              <a:t>A joint model &amp; research board — your senior analysts and quants with Testahil — approving upgrades, auditing calibration, and resourcing the expansion to full MENA coverage.</a:t>
-            </a:r>
-            <a:endParaRPr lang="en-US" sz="1150" dirty="0"/>
-          </a:p>
-        </p:txBody>
-      </p:sp>
-      <p:sp>
-        <p:nvSpPr>
-          <p:cNvPr id="13" name="Shape 11"/>
-          <p:cNvSpPr/>
-          <p:nvPr/>
-        </p:nvSpPr>
-        <p:spPr>
-          <a:xfrm>
-            <a:off x="594360" y="5120640"/>
-            <a:ext cx="11000232" cy="841248"/>
-          </a:xfrm>
-          <a:prstGeom prst="roundRect">
-            <a:avLst>
-              <a:gd name="adj" fmla="val 7609"/>
-            </a:avLst>
-          </a:prstGeom>
-          <a:solidFill>
-            <a:srgbClr val="F3ECD9"/>
-          </a:solidFill>
-          <a:ln w="12700">
-            <a:solidFill>
-              <a:srgbClr val="E2D5B4"/>
-            </a:solidFill>
-            <a:prstDash val="solid"/>
-          </a:ln>
-        </p:spPr>
-      </p:sp>
-      <p:sp>
-        <p:nvSpPr>
-          <p:cNvPr id="14" name="Text 12"/>
-          <p:cNvSpPr/>
-          <p:nvPr/>
-        </p:nvSpPr>
-        <p:spPr>
-          <a:xfrm>
-            <a:off x="850392" y="5230368"/>
-            <a:ext cx="10515600" cy="621792"/>
-          </a:xfrm>
-          <a:prstGeom prst="rect">
-            <a:avLst/>
-          </a:prstGeom>
-          <a:noFill/>
-          <a:ln/>
-        </p:spPr>
-        <p:txBody>
-          <a:bodyPr wrap="square" lIns="0" tIns="0" rIns="0" bIns="0" rtlCol="0" anchor="ctr"/>
-          <a:lstStyle/>
-          <a:p>
-            <a:pPr indent="0" marL="0">
-              <a:buNone/>
-            </a:pPr>
-            <a:r>
-              <a:rPr lang="en-US" sz="1250" b="1" dirty="0">
-                <a:solidFill>
-                  <a:srgbClr val="8A7440"/>
-                </a:solidFill>
-                <a:latin typeface="Arial" pitchFamily="34" charset="0"/>
-                <a:ea typeface="Arial" pitchFamily="34" charset="-122"/>
-                <a:cs typeface="Arial" pitchFamily="34" charset="-120"/>
-              </a:rPr>
-              <a:t>THE GATE, BEFORE DAY ONE — </a:t>
-            </a:r>
-            <a:pPr indent="0" marL="0">
-              <a:buNone/>
-            </a:pPr>
-            <a:r>
-              <a:rPr lang="en-US" sz="1250" dirty="0">
-                <a:solidFill>
-                  <a:srgbClr val="0E2726"/>
-                </a:solidFill>
-                <a:latin typeface="Arial" pitchFamily="34" charset="0"/>
-                <a:ea typeface="Arial" pitchFamily="34" charset="-122"/>
-                <a:cs typeface="Arial" pitchFamily="34" charset="-120"/>
-              </a:rPr>
-              <a:t>an agreed licence price, a named budget holder, a procurement timeline. The pilot is free; unpaid consulting is not on the menu.</a:t>
-            </a:r>
-            <a:endParaRPr lang="en-US" sz="1250" dirty="0"/>
-          </a:p>
-        </p:txBody>
-      </p:sp>
-      <p:sp>
-        <p:nvSpPr>
-          <p:cNvPr id="15" name="Text 13"/>
-          <p:cNvSpPr/>
-          <p:nvPr/>
-        </p:nvSpPr>
-        <p:spPr>
-          <a:xfrm>
-            <a:off x="594360" y="6172200"/>
-            <a:ext cx="10972800" cy="411480"/>
-          </a:xfrm>
-          <a:prstGeom prst="rect">
-            <a:avLst/>
-          </a:prstGeom>
-          <a:noFill/>
-          <a:ln/>
-        </p:spPr>
-        <p:txBody>
-          <a:bodyPr wrap="square" lIns="0" tIns="0" rIns="0" bIns="0" rtlCol="0" anchor="ctr"/>
-          <a:lstStyle/>
-          <a:p>
-            <a:pPr indent="0" marL="0">
-              <a:buNone/>
-            </a:pPr>
-            <a:r>
-              <a:rPr lang="en-US" sz="1450" i="1" dirty="0">
-                <a:solidFill>
-                  <a:srgbClr val="0E2726"/>
-                </a:solidFill>
-                <a:latin typeface="Arial" pitchFamily="34" charset="0"/>
-                <a:ea typeface="Arial" pitchFamily="34" charset="-122"/>
-                <a:cs typeface="Arial" pitchFamily="34" charset="-120"/>
-              </a:rPr>
-              <a:t>What we bring: the engine, the ledger, the discipline. What we ask: your umbrella, your licence, your scale — answered in 3 months, not 6.</a:t>
-            </a:r>
-            <a:endParaRPr lang="en-US" sz="1450" dirty="0"/>
-          </a:p>
-        </p:txBody>
-      </p:sp>
-      <p:sp>
-        <p:nvSpPr>
-          <p:cNvPr id="16" name="Text 14"/>
+              <a:t>What we bring: the engine, the ledger, the discipline. What we ask: your umbrella, your licence, your scale.</a:t>
+            </a:r>
+            <a:endParaRPr lang="en-US" sz="1500" dirty="0"/>
+          </a:p>
+        </p:txBody>
+      </p:sp>
+      <p:sp>
+        <p:nvSpPr>
+          <p:cNvPr id="6" name="Text 3"/>
           <p:cNvSpPr/>
           <p:nvPr/>
         </p:nvSpPr>

</xml_diff>

<commit_message>
Deck v5: say the design fraction and the live record together, always
The miss headline "1 in 10 misses. Here is ours." and the cover kicker
"One in ten misses. On schedule." were being read as the live tally
(one miss in ten graded) when the actual record is one miss in THIRTEEN
graded — the 1-in-10 is the 90% band's design fraction, not a score.
Both lines now state the two numbers side by side: the miss slide reads
"1 in 10 is designed to miss. Our record: 1 of 13." and the cover reads
"One in ten lands outside — by design. So far, one of thirteen has."
The speaker notes log the rewording and the standing rule it produced:
never present the spec without the record.

Co-Authored-By: Claude Fable 5 <noreply@anthropic.com>
Claude-Session: https://claude.ai/code/session_019HtsB7KapvkSNaceBBiqHq
</commit_message>
<xml_diff>
--- a/docs/partnership/Testahil_partnership_18_August_2026.pptx
+++ b/docs/partnership/Testahil_partnership_18_August_2026.pptx
@@ -1291,7 +1291,7 @@
 Distribution (vs. a tip) — a tip is one number ("buy at 50, target 65"). A distribution is the whole spread of where the price could land, with a probability on each zone. We sell the spread, never the single number.
 The 90% band — the price range expected to contain the real outcome nine times out of ten. A promise about frequency across many forecasts, not a guarantee about any one stock.
 Backtest window — one historical test: stand at a past date, forecast forward using only what was known then, then check what actually happened.
-"One in ten misses. On schedule." — the headline defence: a 90% band that never missed would simply be too wide to be worth anything. Misses arriving at the promised rate is the system working.
+"One in ten lands outside — by design. So far, one of thirteen has." — the headline defence in two halves: the SPEC (a 90% band must miss ~10% or it is too wide to be worth anything) and the LIVE TALLY (1 miss in 13 graded forecasts). [REWORDED 18-Aug v5: an earlier draft read "One in ten misses. On schedule." — which was misread as the tally. Design fraction and record now always appear together; never present one without the other.]
 ——— HOW THESE NUMBERS WERE COMPUTED (18-Aug-2026, live repo) ———
 91 — instruments in the persistent library engine/raw_ohlc/{MARKET}/: EG 37, AE 28 (19 ADX + 9 DFM), SA 11, IN/KR/QA/US 3 each, gold+silver 2, platinum 1. 8 markets = 7 equity markets + metals.
 "A full study behind every one" — 91 distinct names carry a Valuation_Study PDF in files/ (80 with the _public suffix + the Aug-2026 batch without it); every one of the 88 equities also has a live fair value in assets/data.js (fair.base present for 88 of 88).
@@ -2351,7 +2351,7 @@
 Calibration — stated odds matching reality. A properly calibrated 90% band MUST miss about one time in ten; misses arriving on schedule is evidence the system works, not evidence it broke.
 ₩ — Korean won; Samsung trades in Seoul.
 ——— HOW THESE NUMBERS WERE COMPUTED ———
-1 in 10 — the complement of the 90% design target (live backtest miss rate 9.4%), the illustrative fraction, not a separately-computed number.
+1 in 10 vs 1 of 13 — two different numbers, now both in the headline so neither can be mistaken for the other. "1 in 10" is the DESIGN fraction: the complement of the 90% target (live backtest miss rate 9.4%), not a tally. "1 of 13" is the LIVE RECORD: 13 graded ledger forecasts, one miss (7.7% — at/below the designed rate, as it should be on a small sample). [REWORDED 18-Aug v5 after the earlier headline "1 in 10 misses. Here is ours." was read as claiming one miss in ten graded — say the spec and the record together, always.]
 Samsung figures — that ledger row's own immutable fields (anchor 26-Jun-2026 at 339,500; band 277,676–430,413; realized 254,000; graded 27-Jul-2026). Unchanged since grading.
 12 of 13 — assets/data.js LEDGER rows with realized_close populated: 13 graded (all 1-month so far), 12 inside their [p5,p95]. The graded names: PHDC, TMGH, EMFD, OCDI, ORHD, COMI, Gold, Silver, Samsung (miss), Kakao, LGES, TMPV, QNB.
 "Ours started in June" — earliest ledger anchor 11-Jun-2026.</a:t>
@@ -3621,7 +3621,7 @@
         <p:spPr>
           <a:xfrm>
             <a:off x="594360" y="5742432"/>
-            <a:ext cx="8229600" cy="457200"/>
+            <a:ext cx="9601200" cy="457200"/>
           </a:xfrm>
           <a:prstGeom prst="rect">
             <a:avLst/>
@@ -3637,7 +3637,7 @@
               <a:buNone/>
             </a:pPr>
             <a:r>
-              <a:rPr lang="en-US" sz="1800" i="1" dirty="0">
+              <a:rPr lang="en-US" sz="1700" i="1" dirty="0">
                 <a:solidFill>
                   <a:srgbClr val="FFFFFF"/>
                 </a:solidFill>
@@ -3645,9 +3645,9 @@
                 <a:ea typeface="Arial" pitchFamily="34" charset="-122"/>
                 <a:cs typeface="Arial" pitchFamily="34" charset="-120"/>
               </a:rPr>
-              <a:t>One in ten misses. On schedule. In public.</a:t>
-            </a:r>
-            <a:endParaRPr lang="en-US" sz="1800" dirty="0"/>
+              <a:t>One in ten lands outside — by design. So far, one of thirteen has.</a:t>
+            </a:r>
+            <a:endParaRPr lang="en-US" sz="1700" dirty="0"/>
           </a:p>
         </p:txBody>
       </p:sp>
@@ -14436,7 +14436,7 @@
         <p:spPr>
           <a:xfrm>
             <a:off x="594360" y="713232"/>
-            <a:ext cx="10972800" cy="1051560"/>
+            <a:ext cx="11064240" cy="1051560"/>
           </a:xfrm>
           <a:prstGeom prst="rect">
             <a:avLst/>
@@ -14474,7 +14474,7 @@
                 <a:ea typeface="Arial" pitchFamily="34" charset="-122"/>
                 <a:cs typeface="Arial" pitchFamily="34" charset="-120"/>
               </a:rPr>
-              <a:t>misses. Here is ours.</a:t>
+              <a:t>is designed to miss. Our record: 1 of 13.</a:t>
             </a:r>
             <a:endParaRPr lang="en-US" sz="6600" dirty="0"/>
           </a:p>

</xml_diff>